<commit_message>
Add Session 7 content and related updates
</commit_message>
<xml_diff>
--- a/lectures/Session04-Discovery.pptx
+++ b/lectures/Session04-Discovery.pptx
@@ -19,9 +19,10 @@
     <p:sldId id="267" r:id="rId13"/>
     <p:sldId id="268" r:id="rId14"/>
     <p:sldId id="269" r:id="rId15"/>
+    <p:sldId id="270" r:id="rId16"/>
   </p:sldIdLst>
   <p:notesMasterIdLst>
-    <p:notesMasterId r:id="rId16"/>
+    <p:notesMasterId r:id="rId17"/>
   </p:notesMasterIdLst>
   <p:sldSz cx="12161520" cy="6858000"/>
   <p:notesSz cx="6858000" cy="12161520"/>
@@ -603,7 +604,7 @@
           <a:p>
             <a:r>
               <a:rPr lang="en-US" dirty="0"/>
-              <a:t>This sets up the two examples so they don't appear out of nowhere. Give the scenario: you have a candidate need (commuter parking) but haven't interviewed a real commuter yet, so you build a persona as a working hypothesis that tells you what to go verify. Stress that BOTH upcoming personas are the same persona, same topic, on purpose — so the only variable is how it was made. Prime the compare: as each appears, ask 'could I trust this, and what's evidence vs. guess?' Don't reveal which is which yet — let the Busy Ben slide land the contrast.</a:t>
+              <a:t>Set expectations first: the real conversation is required (next slides / the assignment); the persona is a supplement for needs you can't reach directly — and everyone builds one, for the experience. The whole point is intellectual honesty: separating what you actually know from what you're guessing. The [E]/[A] tagging is the mechanism. Keep it modest — about an hour of gathering readily-available evidence, not a research project. Then transition: let's look at a good one and a bad one.</a:t>
             </a:r>
             <a:endParaRPr lang="en-US" dirty="0"/>
           </a:p>
@@ -691,7 +692,7 @@
           <a:p>
             <a:r>
               <a:rPr lang="en-US" dirty="0"/>
-              <a:t>Walk it slowly and point at the tags. The key move: every claim says where it came from — [E] with a source, or [A] as an honest guess. Note that the 'what better looks like' line is tagged [A] because it came from the founder, not a user — a very common place people smuggle in their own solution as if it were a finding. Highlight the two things that make this trustworthy: the Sources line, and the 'To verify' list (it names what you still don't know). And the honest 'medium confidence.' Ask the room: what would you go confirm first? Then flip to Ben.</a:t>
+              <a:t>This sets up the two examples so they don't appear out of nowhere. Give the scenario: you have a candidate need (commuter parking) but haven't interviewed a real commuter yet, so you build a persona as a working hypothesis that tells you what to go verify. Stress that BOTH upcoming personas are the same persona, same topic, on purpose — so the only variable is how it was made. Prime the compare: as each appears, ask 'could I trust this, and what's evidence vs. guess?' Don't reveal which is which yet — let the Busy Ben slide land the contrast.</a:t>
             </a:r>
             <a:endParaRPr lang="en-US" dirty="0"/>
           </a:p>
@@ -779,7 +780,7 @@
           <a:p>
             <a:r>
               <a:rPr lang="en-US" dirty="0"/>
-              <a:t>The trap to name: Ben reads better than Cara — it's tidy, specific, confident — and that's exactly why it's dangerous. Ask the room to spot the problems before you reveal the callout: none of it has a source, nothing is tagged as a guess, and the money line is a hypothetical stated as fact. Contrast directly with Cara: Cara is messier but honest — you know what she knows and what she doesn't. Bottom line for them: when they build their own persona for the assignment, it should look like Cara, not Ben. Better to admit low confidence than to invent certainty.</a:t>
+              <a:t>Walk it slowly and point at the tags. The key move: every claim says where it came from — [E] with a source, or [A] as an honest guess. Note that the 'what better looks like' line is tagged [A] because it came from the founder, not a user — a very common place people smuggle in their own solution as if it were a finding. Highlight the two things that make this trustworthy: the Sources line, and the 'To verify' list (it names what you still don't know). And the honest 'medium confidence.' Ask the room: what would you go confirm first? Then flip to Ben.</a:t>
             </a:r>
             <a:endParaRPr lang="en-US" dirty="0"/>
           </a:p>
@@ -867,7 +868,7 @@
           <a:p>
             <a:r>
               <a:rPr lang="en-US" dirty="0"/>
-              <a:t>Hand out Discovery-Notes.md. The non-negotiable: everyone must talk to at least one real person who genuinely has the problem — not a hallway 'sure, I'd use that.' They find their own people; we have no seeded users this iteration. The persona is a required supplement, kept modest. Reassure them that discovering a problem ISN'T real is a great result, not a failure — honest discovery is the grade, not confirmation of their idea. Remind them of consent/ethics and that this feeds directly into the Product Definition Brief next week.</a:t>
+              <a:t>The trap to name: Ben reads better than Cara — it's tidy, specific, confident — and that's exactly why it's dangerous. Ask the room to spot the problems before you reveal the callout: none of it has a source, nothing is tagged as a guess, and the money line is a hypothetical stated as fact. Contrast directly with Cara: Cara is messier but honest — you know what she knows and what she doesn't. Bottom line for them: when they build their own persona for the assignment, it should look like Cara, not Ben. Better to admit low confidence than to invent certainty.</a:t>
             </a:r>
             <a:endParaRPr lang="en-US" dirty="0"/>
           </a:p>
@@ -955,7 +956,7 @@
           <a:p>
             <a:r>
               <a:rPr lang="en-US" dirty="0"/>
-              <a:t>Close on the one-liner — it's the whole method in a sentence. Recap the three rules one more time if there's a beat. Preview Week 3: they'll turn their discovery into a Product Definition Brief (users, needs, success criteria), so the quality of this week's conversations directly determines how strong that brief is. Make the deliverables and dates concrete before they leave.</a:t>
+              <a:t>Hand out Discovery-Notes.md. The non-negotiable: everyone must talk to at least one real person who genuinely has the problem — not a hallway 'sure, I'd use that.' They find their own people; we have no seeded users this iteration. The persona is a required supplement, kept modest. Reassure them that discovering a problem ISN'T real is a great result, not a failure — honest discovery is the grade, not confirmation of their idea. Remind them of consent/ethics and that this feeds directly into the Product Definition Brief next week.</a:t>
             </a:r>
             <a:endParaRPr lang="en-US" dirty="0"/>
           </a:p>
@@ -979,6 +980,94 @@
             <a:fld id="{F7021451-1387-4CA6-816F-3879F97B5CBC}" type="slidenum">
               <a:rPr lang="en-US"/>
               <a:t>14</a:t>
+            </a:fld>
+            <a:endParaRPr lang="en-US"/>
+          </a:p>
+        </p:txBody>
+      </p:sp>
+    </p:spTree>
+    <p:extLst>
+      <p:ext uri="{BB962C8B-B14F-4D97-AF65-F5344CB8AC3E}">
+        <p14:creationId xmlns:p14="http://schemas.microsoft.com/office/powerpoint/2010/main" val="1024086991"/>
+      </p:ext>
+    </p:extLst>
+  </p:cSld>
+  <p:clrMapOvr>
+    <a:masterClrMapping/>
+  </p:clrMapOvr>
+</p:notes>
+</file>
+
+<file path=ppt/notesSlides/notesSlide15.xml><?xml version="1.0" encoding="utf-8"?>
+<p:notes xmlns:a="http://schemas.openxmlformats.org/drawingml/2006/main" xmlns:r="http://schemas.openxmlformats.org/officeDocument/2006/relationships" xmlns:p="http://schemas.openxmlformats.org/presentationml/2006/main">
+  <p:cSld>
+    <p:spTree>
+      <p:nvGrpSpPr>
+        <p:cNvPr id="1" name=""/>
+        <p:cNvGrpSpPr/>
+        <p:nvPr/>
+      </p:nvGrpSpPr>
+      <p:grpSpPr>
+        <a:xfrm>
+          <a:off x="0" y="0"/>
+          <a:ext cx="0" cy="0"/>
+          <a:chOff x="0" y="0"/>
+          <a:chExt cx="0" cy="0"/>
+        </a:xfrm>
+      </p:grpSpPr>
+      <p:sp>
+        <p:nvSpPr>
+          <p:cNvPr id="2" name="Slide Image Placeholder 1"/>
+          <p:cNvSpPr>
+            <a:spLocks noGrp="1" noRot="1" noChangeAspect="1"/>
+          </p:cNvSpPr>
+          <p:nvPr>
+            <p:ph type="sldImg"/>
+          </p:nvPr>
+        </p:nvSpPr>
+        <p:spPr/>
+      </p:sp>
+      <p:sp>
+        <p:nvSpPr>
+          <p:cNvPr id="3" name="Notes Placeholder 2"/>
+          <p:cNvSpPr>
+            <a:spLocks noGrp="1"/>
+          </p:cNvSpPr>
+          <p:nvPr>
+            <p:ph type="body" idx="1"/>
+          </p:nvPr>
+        </p:nvSpPr>
+        <p:spPr/>
+        <p:txBody>
+          <a:bodyPr/>
+          <a:lstStyle/>
+          <a:p>
+            <a:r>
+              <a:rPr lang="en-US" dirty="0"/>
+              <a:t>Close on the one-liner — it's the whole method in a sentence. Recap the three rules one more time if there's a beat. Preview Week 3: they'll turn their discovery into a Product Definition Brief (users, needs, success criteria), so the quality of this week's conversations directly determines how strong that brief is. Make the deliverables and dates concrete before they leave.</a:t>
+            </a:r>
+            <a:endParaRPr lang="en-US" dirty="0"/>
+          </a:p>
+        </p:txBody>
+      </p:sp>
+      <p:sp>
+        <p:nvSpPr>
+          <p:cNvPr id="4" name="Slide Number Placeholder 3"/>
+          <p:cNvSpPr>
+            <a:spLocks noGrp="1"/>
+          </p:cNvSpPr>
+          <p:nvPr>
+            <p:ph type="sldNum" sz="quarter" idx="10"/>
+          </p:nvPr>
+        </p:nvSpPr>
+        <p:spPr/>
+        <p:txBody>
+          <a:bodyPr/>
+          <a:lstStyle/>
+          <a:p>
+            <a:fld id="{F7021451-1387-4CA6-816F-3879F97B5CBC}" type="slidenum">
+              <a:rPr lang="en-US"/>
+              <a:t>15</a:t>
             </a:fld>
             <a:endParaRPr lang="en-US"/>
           </a:p>
@@ -1571,7 +1660,7 @@
           <a:p>
             <a:r>
               <a:rPr lang="en-US" dirty="0"/>
-              <a:t>This is the heart of the session — protect the time. Form triads quickly (a group of four can add a second observer). Hand out the prompt cards; each person, when it's their turn to be 'user,' picks a real problem they genuinely have and answers honestly. Keep it strict: interviewers may NOT pitch or propose solutions — only ask about the user's life and past behavior. Call the rotations yourself with the timer so all three rounds happen (that's why it's three rounds, not two — three roles). Circulate and gently flag leading questions you overhear. Save ~4 minutes at the end to debrief as a class: which leading questions slipped in, what real need surprised you, what was the hardest habit to break. If you're short on time, cut to two rounds rather than skipping the debrief. One more thing to flag: because the User picks the topic, the Interviewer starts cold — point them to the interviewer FUNNEL on the prompt card (open the area, get the last real instance, follow the workaround, ask 'why' 2-3 times, then reflect it back). That funnel plus the reflect-back move is how they reach the real, unspoken problem in five minutes on a topic they knew nothing about.</a:t>
+              <a:t>Two minutes, and run it as a gate rather than a lecture — you just taught the norms, so this is the confirmation before they go talk to real humans this week. Read the four aloud and ask for hands on each; a room that can't raise hands on "anonymize your notes" hasn't read the ethics handout, and that's worth knowing before Thursday. The two bands are the parts the norms slide doesn't cover and the reading does: the IRB boundary (classroom project, not research — but publishing changes the answer, so come ask) and the power imbalance, which is the one students trip on because their easiest interviewees are exactly the people who can least comfortably refuse.</a:t>
             </a:r>
             <a:endParaRPr lang="en-US" dirty="0"/>
           </a:p>
@@ -1659,7 +1748,7 @@
           <a:p>
             <a:r>
               <a:rPr lang="en-US" dirty="0"/>
-              <a:t>Set expectations first: the real conversation is required (next slides / the assignment); the persona is a supplement for needs you can't reach directly — and everyone builds one, for the experience. The whole point is intellectual honesty: separating what you actually know from what you're guessing. The [E]/[A] tagging is the mechanism. Keep it modest — about an hour of gathering readily-available evidence, not a research project. Then transition: let's look at a good one and a bad one.</a:t>
+              <a:t>This is the heart of the session — protect the time. Form triads quickly (a group of four can add a second observer). Hand out the prompt cards; each person, when it's their turn to be 'user,' picks a real problem they genuinely have and answers honestly. Keep it strict: interviewers may NOT pitch or propose solutions — only ask about the user's life and past behavior. Call the rotations yourself with the timer so all three rounds happen (that's why it's three rounds, not two — three roles). Circulate and gently flag leading questions you overhear. Save ~4 minutes at the end to debrief as a class: which leading questions slipped in, what real need surprised you, what was the hardest habit to break. If you're short on time, cut to two rounds rather than skipping the debrief. One more thing to flag: because the User picks the topic, the Interviewer starts cold — point them to the interviewer FUNNEL on the prompt card (open the area, get the last real instance, follow the workaround, ask 'why' 2-3 times, then reflect it back). That funnel plus the reflect-back move is how they reach the real, unspoken problem in five minutes on a topic they knew nothing about.</a:t>
             </a:r>
             <a:endParaRPr lang="en-US" dirty="0"/>
           </a:p>
@@ -2341,7 +2430,7 @@
                 <a:ea typeface="Calibri" pitchFamily="34" charset="-122"/>
                 <a:cs typeface="Calibri" pitchFamily="34" charset="-120"/>
               </a:rPr>
-              <a:t>PERSONA EXAMPLE — SETUP</a:t>
+              <a:t>WHEN YOU CAN'T REACH A REAL USER</a:t>
             </a:r>
             <a:endParaRPr lang="en-US" sz="1400" dirty="0"/>
           </a:p>
@@ -2380,7 +2469,7 @@
                 <a:ea typeface="Cambria" pitchFamily="34" charset="-122"/>
                 <a:cs typeface="Cambria" pitchFamily="34" charset="-120"/>
               </a:rPr>
-              <a:t>Two personas for the same need</a:t>
+              <a:t>Build an honest persona</a:t>
             </a:r>
             <a:endParaRPr lang="en-US" sz="3100" dirty="0"/>
           </a:p>
@@ -2395,11 +2484,11 @@
         <p:spPr>
           <a:xfrm>
             <a:off x="548640" y="1920240"/>
-            <a:ext cx="11064240" cy="1783080"/>
+            <a:ext cx="11064240" cy="1371600"/>
           </a:xfrm>
           <a:prstGeom prst="roundRect">
             <a:avLst>
-              <a:gd name="adj" fmla="val 4615"/>
+              <a:gd name="adj" fmla="val 6000"/>
             </a:avLst>
           </a:prstGeom>
           <a:solidFill>
@@ -2423,7 +2512,7 @@
         </p:nvSpPr>
         <p:spPr>
           <a:xfrm>
-            <a:off x="914400" y="2395728"/>
+            <a:off x="914400" y="2331720"/>
             <a:ext cx="640080" cy="640080"/>
           </a:xfrm>
           <a:prstGeom prst="ellipse">
@@ -2451,7 +2540,7 @@
         </p:blipFill>
         <p:spPr>
           <a:xfrm>
-            <a:off x="1087222" y="2568550"/>
+            <a:off x="1087222" y="2504542"/>
             <a:ext cx="294437" cy="294437"/>
           </a:xfrm>
           <a:prstGeom prst="rect">
@@ -2468,7 +2557,7 @@
         <p:spPr>
           <a:xfrm>
             <a:off x="1828800" y="1920240"/>
-            <a:ext cx="9509760" cy="1783080"/>
+            <a:ext cx="9509760" cy="1371600"/>
           </a:xfrm>
           <a:prstGeom prst="rect">
             <a:avLst/>
@@ -2482,12 +2571,12 @@
           <a:p>
             <a:pPr indent="0" marL="0">
               <a:lnSpc>
-                <a:spcPct val="106000"/>
+                <a:spcPct val="105000"/>
               </a:lnSpc>
               <a:buNone/>
             </a:pPr>
             <a:r>
-              <a:rPr lang="en-US" sz="1700" b="1" dirty="0">
+              <a:rPr lang="en-US" sz="1700" dirty="0">
                 <a:solidFill>
                   <a:srgbClr val="1E2A36"/>
                 </a:solidFill>
@@ -2495,16 +2584,81 @@
                 <a:ea typeface="Calibri" pitchFamily="34" charset="-122"/>
                 <a:cs typeface="Calibri" pitchFamily="34" charset="-120"/>
               </a:rPr>
-              <a:t>The scenario:  </a:t>
-            </a:r>
+              <a:t>A persona here is NOT an invented character — it's a summary of what you actually found, with every claim labeled.</a:t>
+            </a:r>
+            <a:endParaRPr lang="en-US" sz="1700" dirty="0"/>
+          </a:p>
+        </p:txBody>
+      </p:sp>
+      <p:sp>
+        <p:nvSpPr>
+          <p:cNvPr id="9" name="Text 6"/>
+          <p:cNvSpPr/>
+          <p:nvPr/>
+        </p:nvSpPr>
+        <p:spPr>
+          <a:xfrm>
+            <a:off x="548640" y="3520440"/>
+            <a:ext cx="10972800" cy="365760"/>
+          </a:xfrm>
+          <a:prstGeom prst="rect">
+            <a:avLst/>
+          </a:prstGeom>
+          <a:noFill/>
+          <a:ln/>
+        </p:spPr>
+        <p:txBody>
+          <a:bodyPr wrap="square" lIns="0" tIns="0" rIns="0" bIns="0" rtlCol="0" anchor="ctr"/>
+          <a:lstStyle/>
+          <a:p>
             <a:pPr indent="0" marL="0">
-              <a:lnSpc>
-                <a:spcPct val="106000"/>
-              </a:lnSpc>
-              <a:buNone/>
-            </a:pPr>
-            <a:r>
-              <a:rPr lang="en-US" sz="1700" dirty="0">
+              <a:buNone/>
+            </a:pPr>
+            <a:r>
+              <a:rPr lang="en-US" sz="1600" b="1" dirty="0">
+                <a:solidFill>
+                  <a:srgbClr val="0E6E6D"/>
+                </a:solidFill>
+                <a:latin typeface="Calibri" pitchFamily="34" charset="0"/>
+                <a:ea typeface="Calibri" pitchFamily="34" charset="-122"/>
+                <a:cs typeface="Calibri" pitchFamily="34" charset="-120"/>
+              </a:rPr>
+              <a:t>"Documented honestly" means:</a:t>
+            </a:r>
+            <a:endParaRPr lang="en-US" sz="1600" dirty="0"/>
+          </a:p>
+        </p:txBody>
+      </p:sp>
+      <p:sp>
+        <p:nvSpPr>
+          <p:cNvPr id="10" name="Text 7"/>
+          <p:cNvSpPr/>
+          <p:nvPr/>
+        </p:nvSpPr>
+        <p:spPr>
+          <a:xfrm>
+            <a:off x="914400" y="3931920"/>
+            <a:ext cx="10515600" cy="1828800"/>
+          </a:xfrm>
+          <a:prstGeom prst="rect">
+            <a:avLst/>
+          </a:prstGeom>
+          <a:noFill/>
+          <a:ln/>
+        </p:spPr>
+        <p:txBody>
+          <a:bodyPr wrap="square" lIns="0" tIns="0" rIns="0" bIns="0" rtlCol="0" anchor="t"/>
+          <a:lstStyle/>
+          <a:p>
+            <a:pPr marL="203200" indent="-203200">
+              <a:spcAft>
+                <a:spcPts val="1100"/>
+              </a:spcAft>
+              <a:buSzPct val="100000"/>
+              <a:buChar char="•"/>
+            </a:pPr>
+            <a:r>
+              <a:rPr lang="en-US" sz="1600" dirty="0">
                 <a:solidFill>
                   <a:srgbClr val="1E2A36"/>
                 </a:solidFill>
@@ -2512,169 +2666,54 @@
                 <a:ea typeface="Calibri" pitchFamily="34" charset="-122"/>
                 <a:cs typeface="Calibri" pitchFamily="34" charset="-120"/>
               </a:rPr>
-              <a:t>you're exploring a commuter-parking problem for students, but you haven't reached a real commuter yet. So you sketch a persona as a working hypothesis — a stand-in that tells you where to dig next.</a:t>
-            </a:r>
-            <a:endParaRPr lang="en-US" sz="1700" dirty="0"/>
-          </a:p>
-        </p:txBody>
-      </p:sp>
-      <p:sp>
-        <p:nvSpPr>
-          <p:cNvPr id="9" name="Shape 6"/>
-          <p:cNvSpPr/>
-          <p:nvPr/>
-        </p:nvSpPr>
-        <p:spPr>
-          <a:xfrm>
-            <a:off x="548640" y="3931920"/>
-            <a:ext cx="11064240" cy="1920240"/>
-          </a:xfrm>
-          <a:prstGeom prst="roundRect">
-            <a:avLst>
-              <a:gd name="adj" fmla="val 4286"/>
-            </a:avLst>
-          </a:prstGeom>
-          <a:solidFill>
-            <a:srgbClr val="14233A"/>
-          </a:solidFill>
-          <a:ln/>
-          <a:effectLst>
-            <a:outerShdw sx="100000" sy="100000" kx="0" ky="0" algn="bl" rotWithShape="0" blurRad="88900" dist="38100" dir="5400000">
-              <a:srgbClr val="000000">
-                <a:alpha val="13000"/>
-              </a:srgbClr>
-            </a:outerShdw>
-          </a:effectLst>
-        </p:spPr>
-      </p:sp>
-      <p:sp>
-        <p:nvSpPr>
-          <p:cNvPr id="10" name="Shape 7"/>
-          <p:cNvSpPr/>
-          <p:nvPr/>
-        </p:nvSpPr>
-        <p:spPr>
-          <a:xfrm>
-            <a:off x="914400" y="4480560"/>
-            <a:ext cx="640080" cy="640080"/>
-          </a:xfrm>
-          <a:prstGeom prst="ellipse">
-            <a:avLst/>
-          </a:prstGeom>
-          <a:solidFill>
-            <a:srgbClr val="E8A33D"/>
-          </a:solidFill>
-          <a:ln/>
-        </p:spPr>
-      </p:sp>
-      <p:pic>
-        <p:nvPicPr>
-          <p:cNvPr id="11" name="Image 1" descr="preencoded.png">    </p:cNvPr>
-          <p:cNvPicPr>
-            <a:picLocks noChangeAspect="1"/>
-          </p:cNvPicPr>
-          <p:nvPr/>
-        </p:nvPicPr>
-        <p:blipFill>
-          <a:blip r:embed="rId2"/>
-          <a:stretch>
-            <a:fillRect/>
-          </a:stretch>
-        </p:blipFill>
-        <p:spPr>
-          <a:xfrm>
-            <a:off x="1087222" y="4653382"/>
-            <a:ext cx="294437" cy="294437"/>
-          </a:xfrm>
-          <a:prstGeom prst="rect">
-            <a:avLst/>
-          </a:prstGeom>
-        </p:spPr>
-      </p:pic>
-      <p:sp>
-        <p:nvSpPr>
-          <p:cNvPr id="12" name="Text 8"/>
-          <p:cNvSpPr/>
-          <p:nvPr/>
-        </p:nvSpPr>
-        <p:spPr>
-          <a:xfrm>
-            <a:off x="1828800" y="4069080"/>
-            <a:ext cx="9144000" cy="457200"/>
-          </a:xfrm>
-          <a:prstGeom prst="rect">
-            <a:avLst/>
-          </a:prstGeom>
-          <a:noFill/>
-          <a:ln/>
-        </p:spPr>
-        <p:txBody>
-          <a:bodyPr wrap="square" lIns="0" tIns="0" rIns="0" bIns="0" rtlCol="0" anchor="ctr"/>
-          <a:lstStyle/>
-          <a:p>
-            <a:pPr indent="0" marL="0">
-              <a:buNone/>
-            </a:pPr>
-            <a:r>
-              <a:rPr lang="en-US" sz="1700" b="1" dirty="0">
-                <a:solidFill>
-                  <a:srgbClr val="E8A33D"/>
-                </a:solidFill>
-                <a:latin typeface="Calibri" pitchFamily="34" charset="0"/>
-                <a:ea typeface="Calibri" pitchFamily="34" charset="-122"/>
-                <a:cs typeface="Calibri" pitchFamily="34" charset="-120"/>
-              </a:rPr>
-              <a:t>What's coming — and what to watch for</a:t>
-            </a:r>
-            <a:endParaRPr lang="en-US" sz="1700" dirty="0"/>
-          </a:p>
-        </p:txBody>
-      </p:sp>
-      <p:sp>
-        <p:nvSpPr>
-          <p:cNvPr id="13" name="Text 9"/>
-          <p:cNvSpPr/>
-          <p:nvPr/>
-        </p:nvSpPr>
-        <p:spPr>
-          <a:xfrm>
-            <a:off x="1828800" y="4572000"/>
-            <a:ext cx="9509760" cy="1188720"/>
-          </a:xfrm>
-          <a:prstGeom prst="rect">
-            <a:avLst/>
-          </a:prstGeom>
-          <a:noFill/>
-          <a:ln/>
-        </p:spPr>
-        <p:txBody>
-          <a:bodyPr wrap="square" lIns="0" tIns="0" rIns="0" bIns="0" rtlCol="0" anchor="t"/>
-          <a:lstStyle/>
-          <a:p>
-            <a:pPr indent="0" marL="0">
-              <a:lnSpc>
-                <a:spcPct val="106000"/>
-              </a:lnSpc>
-              <a:buNone/>
-            </a:pPr>
-            <a:r>
-              <a:rPr lang="en-US" sz="1550" dirty="0">
-                <a:solidFill>
-                  <a:srgbClr val="CFE0E9"/>
-                </a:solidFill>
-                <a:latin typeface="Calibri" pitchFamily="34" charset="0"/>
-                <a:ea typeface="Calibri" pitchFamily="34" charset="-122"/>
-                <a:cs typeface="Calibri" pitchFamily="34" charset="-120"/>
-              </a:rPr>
-              <a:t>Next are two attempts at that same persona — same topic on purpose, so the only difference is the method. As each appears, ask yourself: could I trust this? What here is real evidence, and what's just a guess?</a:t>
-            </a:r>
-            <a:endParaRPr lang="en-US" sz="1550" dirty="0"/>
-          </a:p>
-        </p:txBody>
-      </p:sp>
-      <p:sp>
-        <p:nvSpPr>
-          <p:cNvPr id="14" name="Text 10"/>
+              <a:t>Tag every claim: [E] evidence (with a source) or [A] assumption (a labeled guess)</a:t>
+            </a:r>
+            <a:endParaRPr lang="en-US" sz="1600" dirty="0"/>
+          </a:p>
+          <a:p>
+            <a:pPr marL="203200" indent="-203200">
+              <a:spcAft>
+                <a:spcPts val="1100"/>
+              </a:spcAft>
+              <a:buSzPct val="100000"/>
+              <a:buChar char="•"/>
+            </a:pPr>
+            <a:r>
+              <a:rPr lang="en-US" sz="1600" dirty="0">
+                <a:solidFill>
+                  <a:srgbClr val="1E2A36"/>
+                </a:solidFill>
+                <a:latin typeface="Calibri" pitchFamily="34" charset="0"/>
+                <a:ea typeface="Calibri" pitchFamily="34" charset="-122"/>
+                <a:cs typeface="Calibri" pitchFamily="34" charset="-120"/>
+              </a:rPr>
+              <a:t>No invented facts — a guess is marked [A], never dressed up as fact</a:t>
+            </a:r>
+            <a:endParaRPr lang="en-US" sz="1600" dirty="0"/>
+          </a:p>
+          <a:p>
+            <a:pPr marL="203200" indent="-203200">
+              <a:buSzPct val="100000"/>
+              <a:buChar char="•"/>
+            </a:pPr>
+            <a:r>
+              <a:rPr lang="en-US" sz="1600" dirty="0">
+                <a:solidFill>
+                  <a:srgbClr val="1E2A36"/>
+                </a:solidFill>
+                <a:latin typeface="Calibri" pitchFamily="34" charset="0"/>
+                <a:ea typeface="Calibri" pitchFamily="34" charset="-122"/>
+                <a:cs typeface="Calibri" pitchFamily="34" charset="-120"/>
+              </a:rPr>
+              <a:t>List your sources, and the top assumptions you'd verify in a real conversation</a:t>
+            </a:r>
+            <a:endParaRPr lang="en-US" sz="1600" dirty="0"/>
+          </a:p>
+        </p:txBody>
+      </p:sp>
+      <p:sp>
+        <p:nvSpPr>
+          <p:cNvPr id="11" name="Text 8"/>
           <p:cNvSpPr/>
           <p:nvPr/>
         </p:nvSpPr>
@@ -2713,7 +2752,7 @@
       </p:sp>
       <p:sp>
         <p:nvSpPr>
-          <p:cNvPr id="15" name="Text 11"/>
+          <p:cNvPr id="12" name="Text 9"/>
           <p:cNvSpPr/>
           <p:nvPr/>
         </p:nvSpPr>
@@ -2835,7 +2874,7 @@
                 <a:ea typeface="Calibri" pitchFamily="34" charset="-122"/>
                 <a:cs typeface="Calibri" pitchFamily="34" charset="-120"/>
               </a:rPr>
-              <a:t>PERSONA EXAMPLE — HONEST</a:t>
+              <a:t>PERSONA EXAMPLE — SETUP</a:t>
             </a:r>
             <a:endParaRPr lang="en-US" sz="1400" dirty="0"/>
           </a:p>
@@ -2874,7 +2913,7 @@
                 <a:ea typeface="Cambria" pitchFamily="34" charset="-122"/>
                 <a:cs typeface="Cambria" pitchFamily="34" charset="-120"/>
               </a:rPr>
-              <a:t>"Commuter Cara" (evidence-tagged)</a:t>
+              <a:t>Two personas for the same need</a:t>
             </a:r>
             <a:endParaRPr lang="en-US" sz="3100" dirty="0"/>
           </a:p>
@@ -2888,16 +2927,16 @@
         </p:nvSpPr>
         <p:spPr>
           <a:xfrm>
-            <a:off x="548640" y="1874520"/>
-            <a:ext cx="11064240" cy="3063240"/>
+            <a:off x="548640" y="1920240"/>
+            <a:ext cx="11064240" cy="1783080"/>
           </a:xfrm>
           <a:prstGeom prst="roundRect">
             <a:avLst>
-              <a:gd name="adj" fmla="val 2687"/>
+              <a:gd name="adj" fmla="val 4615"/>
             </a:avLst>
           </a:prstGeom>
           <a:solidFill>
-            <a:srgbClr val="EAF4EE"/>
+            <a:srgbClr val="F2F6F8"/>
           </a:solidFill>
           <a:ln/>
           <a:effectLst>
@@ -2911,14 +2950,58 @@
       </p:sp>
       <p:sp>
         <p:nvSpPr>
-          <p:cNvPr id="6" name="Text 4"/>
-          <p:cNvSpPr/>
-          <p:nvPr/>
-        </p:nvSpPr>
-        <p:spPr>
-          <a:xfrm>
-            <a:off x="868680" y="2057400"/>
-            <a:ext cx="10424160" cy="2377440"/>
+          <p:cNvPr id="6" name="Shape 4"/>
+          <p:cNvSpPr/>
+          <p:nvPr/>
+        </p:nvSpPr>
+        <p:spPr>
+          <a:xfrm>
+            <a:off x="914400" y="2395728"/>
+            <a:ext cx="640080" cy="640080"/>
+          </a:xfrm>
+          <a:prstGeom prst="ellipse">
+            <a:avLst/>
+          </a:prstGeom>
+          <a:solidFill>
+            <a:srgbClr val="12908F"/>
+          </a:solidFill>
+          <a:ln/>
+        </p:spPr>
+      </p:sp>
+      <p:pic>
+        <p:nvPicPr>
+          <p:cNvPr id="7" name="Image 0" descr="preencoded.png">    </p:cNvPr>
+          <p:cNvPicPr>
+            <a:picLocks noChangeAspect="1"/>
+          </p:cNvPicPr>
+          <p:nvPr/>
+        </p:nvPicPr>
+        <p:blipFill>
+          <a:blip r:embed="rId1"/>
+          <a:stretch>
+            <a:fillRect/>
+          </a:stretch>
+        </p:blipFill>
+        <p:spPr>
+          <a:xfrm>
+            <a:off x="1087222" y="2568550"/>
+            <a:ext cx="294437" cy="294437"/>
+          </a:xfrm>
+          <a:prstGeom prst="rect">
+            <a:avLst/>
+          </a:prstGeom>
+        </p:spPr>
+      </p:pic>
+      <p:sp>
+        <p:nvSpPr>
+          <p:cNvPr id="8" name="Text 5"/>
+          <p:cNvSpPr/>
+          <p:nvPr/>
+        </p:nvSpPr>
+        <p:spPr>
+          <a:xfrm>
+            <a:off x="1828800" y="1920240"/>
+            <a:ext cx="9509760" cy="1783080"/>
           </a:xfrm>
           <a:prstGeom prst="rect">
             <a:avLst/>
@@ -2927,17 +3010,17 @@
           <a:ln/>
         </p:spPr>
         <p:txBody>
-          <a:bodyPr wrap="square" lIns="0" tIns="0" rIns="0" bIns="0" rtlCol="0" anchor="t"/>
+          <a:bodyPr wrap="square" lIns="0" tIns="0" rIns="0" bIns="0" rtlCol="0" anchor="ctr"/>
           <a:lstStyle/>
           <a:p>
             <a:pPr indent="0" marL="0">
               <a:lnSpc>
-                <a:spcPct val="122000"/>
+                <a:spcPct val="106000"/>
               </a:lnSpc>
               <a:buNone/>
             </a:pPr>
             <a:r>
-              <a:rPr lang="en-US" sz="1550" b="1" dirty="0">
+              <a:rPr lang="en-US" sz="1700" b="1" dirty="0">
                 <a:solidFill>
                   <a:srgbClr val="1E2A36"/>
                 </a:solidFill>
@@ -2945,16 +3028,16 @@
                 <a:ea typeface="Calibri" pitchFamily="34" charset="-122"/>
                 <a:cs typeface="Calibri" pitchFamily="34" charset="-120"/>
               </a:rPr>
-              <a:t>Who:  </a:t>
+              <a:t>The scenario:  </a:t>
             </a:r>
             <a:pPr indent="0" marL="0">
               <a:lnSpc>
-                <a:spcPct val="122000"/>
+                <a:spcPct val="106000"/>
               </a:lnSpc>
               <a:buNone/>
             </a:pPr>
             <a:r>
-              <a:rPr lang="en-US" sz="1550" dirty="0">
+              <a:rPr lang="en-US" sz="1700" dirty="0">
                 <a:solidFill>
                   <a:srgbClr val="1E2A36"/>
                 </a:solidFill>
@@ -2962,170 +3045,30 @@
                 <a:ea typeface="Calibri" pitchFamily="34" charset="-122"/>
                 <a:cs typeface="Calibri" pitchFamily="34" charset="-120"/>
               </a:rPr>
-              <a:t>[E] off-campus student who drives to campus (r/byu threads; my lot observation).  [A] likely a soph/junior with a job.
-</a:t>
-            </a:r>
-            <a:pPr indent="0" marL="0">
-              <a:lnSpc>
-                <a:spcPct val="122000"/>
-              </a:lnSpc>
-              <a:buNone/>
-            </a:pPr>
-            <a:r>
-              <a:rPr lang="en-US" sz="1550" b="1" dirty="0">
-                <a:solidFill>
-                  <a:srgbClr val="1E2A36"/>
-                </a:solidFill>
-                <a:latin typeface="Calibri" pitchFamily="34" charset="0"/>
-                <a:ea typeface="Calibri" pitchFamily="34" charset="-122"/>
-                <a:cs typeface="Calibri" pitchFamily="34" charset="-120"/>
-              </a:rPr>
-              <a:t>Problem:  </a:t>
-            </a:r>
-            <a:pPr indent="0" marL="0">
-              <a:lnSpc>
-                <a:spcPct val="122000"/>
-              </a:lnSpc>
-              <a:buNone/>
-            </a:pPr>
-            <a:r>
-              <a:rPr lang="en-US" sz="1550" dirty="0">
-                <a:solidFill>
-                  <a:srgbClr val="1E2A36"/>
-                </a:solidFill>
-                <a:latin typeface="Calibri" pitchFamily="34" charset="0"/>
-                <a:ea typeface="Calibri" pitchFamily="34" charset="-122"/>
-                <a:cs typeface="Calibri" pitchFamily="34" charset="-120"/>
-              </a:rPr>
-              <a:t>[E] a mid-morning spot is unpredictable and eats time (forum posts; a friend).  [A] makes her late to class.
-</a:t>
-            </a:r>
-            <a:pPr indent="0" marL="0">
-              <a:lnSpc>
-                <a:spcPct val="122000"/>
-              </a:lnSpc>
-              <a:buNone/>
-            </a:pPr>
-            <a:r>
-              <a:rPr lang="en-US" sz="1550" b="1" dirty="0">
-                <a:solidFill>
-                  <a:srgbClr val="1E2A36"/>
-                </a:solidFill>
-                <a:latin typeface="Calibri" pitchFamily="34" charset="0"/>
-                <a:ea typeface="Calibri" pitchFamily="34" charset="-122"/>
-                <a:cs typeface="Calibri" pitchFamily="34" charset="-120"/>
-              </a:rPr>
-              <a:t>Today:  </a:t>
-            </a:r>
-            <a:pPr indent="0" marL="0">
-              <a:lnSpc>
-                <a:spcPct val="122000"/>
-              </a:lnSpc>
-              <a:buNone/>
-            </a:pPr>
-            <a:r>
-              <a:rPr lang="en-US" sz="1550" dirty="0">
-                <a:solidFill>
-                  <a:srgbClr val="1E2A36"/>
-                </a:solidFill>
-                <a:latin typeface="Calibri" pitchFamily="34" charset="0"/>
-                <a:ea typeface="Calibri" pitchFamily="34" charset="-122"/>
-                <a:cs typeface="Calibri" pitchFamily="34" charset="-120"/>
-              </a:rPr>
-              <a:t>[E] arrives 30–45 min early to "camp," or circles the lot.
-</a:t>
-            </a:r>
-            <a:pPr indent="0" marL="0">
-              <a:lnSpc>
-                <a:spcPct val="122000"/>
-              </a:lnSpc>
-              <a:buNone/>
-            </a:pPr>
-            <a:r>
-              <a:rPr lang="en-US" sz="1550" b="1" dirty="0">
-                <a:solidFill>
-                  <a:srgbClr val="1E2A36"/>
-                </a:solidFill>
-                <a:latin typeface="Calibri" pitchFamily="34" charset="0"/>
-                <a:ea typeface="Calibri" pitchFamily="34" charset="-122"/>
-                <a:cs typeface="Calibri" pitchFamily="34" charset="-120"/>
-              </a:rPr>
-              <a:t>Costs:  </a:t>
-            </a:r>
-            <a:pPr indent="0" marL="0">
-              <a:lnSpc>
-                <a:spcPct val="122000"/>
-              </a:lnSpc>
-              <a:buNone/>
-            </a:pPr>
-            <a:r>
-              <a:rPr lang="en-US" sz="1550" dirty="0">
-                <a:solidFill>
-                  <a:srgbClr val="1E2A36"/>
-                </a:solidFill>
-                <a:latin typeface="Calibri" pitchFamily="34" charset="0"/>
-                <a:ea typeface="Calibri" pitchFamily="34" charset="-122"/>
-                <a:cs typeface="Calibri" pitchFamily="34" charset="-120"/>
-              </a:rPr>
-              <a:t>[E] ~30 min/day + real frustration.
-</a:t>
-            </a:r>
-            <a:pPr indent="0" marL="0">
-              <a:lnSpc>
-                <a:spcPct val="122000"/>
-              </a:lnSpc>
-              <a:buNone/>
-            </a:pPr>
-            <a:r>
-              <a:rPr lang="en-US" sz="1550" b="1" dirty="0">
-                <a:solidFill>
-                  <a:srgbClr val="1E2A36"/>
-                </a:solidFill>
-                <a:latin typeface="Calibri" pitchFamily="34" charset="0"/>
-                <a:ea typeface="Calibri" pitchFamily="34" charset="-122"/>
-                <a:cs typeface="Calibri" pitchFamily="34" charset="-120"/>
-              </a:rPr>
-              <a:t>"Better":  </a:t>
-            </a:r>
-            <a:pPr indent="0" marL="0">
-              <a:lnSpc>
-                <a:spcPct val="122000"/>
-              </a:lnSpc>
-              <a:buNone/>
-            </a:pPr>
-            <a:r>
-              <a:rPr lang="en-US" sz="1550" dirty="0">
-                <a:solidFill>
-                  <a:srgbClr val="1E2A36"/>
-                </a:solidFill>
-                <a:latin typeface="Calibri" pitchFamily="34" charset="0"/>
-                <a:ea typeface="Calibri" pitchFamily="34" charset="-122"/>
-                <a:cs typeface="Calibri" pitchFamily="34" charset="-120"/>
-              </a:rPr>
-              <a:t>[A] real-time spot availability — my hypothesis, not a user's.</a:t>
-            </a:r>
-            <a:endParaRPr lang="en-US" sz="1550" dirty="0"/>
-          </a:p>
-        </p:txBody>
-      </p:sp>
-      <p:sp>
-        <p:nvSpPr>
-          <p:cNvPr id="7" name="Shape 5"/>
-          <p:cNvSpPr/>
-          <p:nvPr/>
-        </p:nvSpPr>
-        <p:spPr>
-          <a:xfrm>
-            <a:off x="548640" y="5074920"/>
-            <a:ext cx="11064240" cy="914400"/>
+              <a:t>you're exploring a commuter-parking problem for students, but you haven't reached a real commuter yet. So you sketch a persona as a working hypothesis — a stand-in that tells you where to dig next.</a:t>
+            </a:r>
+            <a:endParaRPr lang="en-US" sz="1700" dirty="0"/>
+          </a:p>
+        </p:txBody>
+      </p:sp>
+      <p:sp>
+        <p:nvSpPr>
+          <p:cNvPr id="9" name="Shape 6"/>
+          <p:cNvSpPr/>
+          <p:nvPr/>
+        </p:nvSpPr>
+        <p:spPr>
+          <a:xfrm>
+            <a:off x="548640" y="3931920"/>
+            <a:ext cx="11064240" cy="1920240"/>
           </a:xfrm>
           <a:prstGeom prst="roundRect">
             <a:avLst>
-              <a:gd name="adj" fmla="val 9000"/>
+              <a:gd name="adj" fmla="val 4286"/>
             </a:avLst>
           </a:prstGeom>
           <a:solidFill>
-            <a:srgbClr val="F2F6F8"/>
+            <a:srgbClr val="14233A"/>
           </a:solidFill>
           <a:ln/>
           <a:effectLst>
@@ -3139,14 +3082,58 @@
       </p:sp>
       <p:sp>
         <p:nvSpPr>
-          <p:cNvPr id="8" name="Text 6"/>
-          <p:cNvSpPr/>
-          <p:nvPr/>
-        </p:nvSpPr>
-        <p:spPr>
-          <a:xfrm>
-            <a:off x="868680" y="5074920"/>
-            <a:ext cx="10424160" cy="914400"/>
+          <p:cNvPr id="10" name="Shape 7"/>
+          <p:cNvSpPr/>
+          <p:nvPr/>
+        </p:nvSpPr>
+        <p:spPr>
+          <a:xfrm>
+            <a:off x="914400" y="4480560"/>
+            <a:ext cx="640080" cy="640080"/>
+          </a:xfrm>
+          <a:prstGeom prst="ellipse">
+            <a:avLst/>
+          </a:prstGeom>
+          <a:solidFill>
+            <a:srgbClr val="E8A33D"/>
+          </a:solidFill>
+          <a:ln/>
+        </p:spPr>
+      </p:sp>
+      <p:pic>
+        <p:nvPicPr>
+          <p:cNvPr id="11" name="Image 1" descr="preencoded.png">    </p:cNvPr>
+          <p:cNvPicPr>
+            <a:picLocks noChangeAspect="1"/>
+          </p:cNvPicPr>
+          <p:nvPr/>
+        </p:nvPicPr>
+        <p:blipFill>
+          <a:blip r:embed="rId2"/>
+          <a:stretch>
+            <a:fillRect/>
+          </a:stretch>
+        </p:blipFill>
+        <p:spPr>
+          <a:xfrm>
+            <a:off x="1087222" y="4653382"/>
+            <a:ext cx="294437" cy="294437"/>
+          </a:xfrm>
+          <a:prstGeom prst="rect">
+            <a:avLst/>
+          </a:prstGeom>
+        </p:spPr>
+      </p:pic>
+      <p:sp>
+        <p:nvSpPr>
+          <p:cNvPr id="12" name="Text 8"/>
+          <p:cNvSpPr/>
+          <p:nvPr/>
+        </p:nvSpPr>
+        <p:spPr>
+          <a:xfrm>
+            <a:off x="1828800" y="4069080"/>
+            <a:ext cx="9144000" cy="457200"/>
           </a:xfrm>
           <a:prstGeom prst="rect">
             <a:avLst/>
@@ -3156,100 +3143,71 @@
         </p:spPr>
         <p:txBody>
           <a:bodyPr wrap="square" lIns="0" tIns="0" rIns="0" bIns="0" rtlCol="0" anchor="ctr"/>
+          <a:lstStyle/>
+          <a:p>
+            <a:pPr indent="0" marL="0">
+              <a:buNone/>
+            </a:pPr>
+            <a:r>
+              <a:rPr lang="en-US" sz="1700" b="1" dirty="0">
+                <a:solidFill>
+                  <a:srgbClr val="E8A33D"/>
+                </a:solidFill>
+                <a:latin typeface="Calibri" pitchFamily="34" charset="0"/>
+                <a:ea typeface="Calibri" pitchFamily="34" charset="-122"/>
+                <a:cs typeface="Calibri" pitchFamily="34" charset="-120"/>
+              </a:rPr>
+              <a:t>What's coming — and what to watch for</a:t>
+            </a:r>
+            <a:endParaRPr lang="en-US" sz="1700" dirty="0"/>
+          </a:p>
+        </p:txBody>
+      </p:sp>
+      <p:sp>
+        <p:nvSpPr>
+          <p:cNvPr id="13" name="Text 9"/>
+          <p:cNvSpPr/>
+          <p:nvPr/>
+        </p:nvSpPr>
+        <p:spPr>
+          <a:xfrm>
+            <a:off x="1828800" y="4572000"/>
+            <a:ext cx="9509760" cy="1188720"/>
+          </a:xfrm>
+          <a:prstGeom prst="rect">
+            <a:avLst/>
+          </a:prstGeom>
+          <a:noFill/>
+          <a:ln/>
+        </p:spPr>
+        <p:txBody>
+          <a:bodyPr wrap="square" lIns="0" tIns="0" rIns="0" bIns="0" rtlCol="0" anchor="t"/>
           <a:lstStyle/>
           <a:p>
             <a:pPr indent="0" marL="0">
               <a:lnSpc>
-                <a:spcPct val="105000"/>
+                <a:spcPct val="106000"/>
               </a:lnSpc>
               <a:buNone/>
             </a:pPr>
             <a:r>
-              <a:rPr lang="en-US" sz="1400" b="1" dirty="0">
-                <a:solidFill>
-                  <a:srgbClr val="0E6E6D"/>
-                </a:solidFill>
-                <a:latin typeface="Calibri" pitchFamily="34" charset="0"/>
-                <a:ea typeface="Calibri" pitchFamily="34" charset="-122"/>
-                <a:cs typeface="Calibri" pitchFamily="34" charset="-120"/>
-              </a:rPr>
-              <a:t>Sources: </a:t>
-            </a:r>
-            <a:pPr indent="0" marL="0">
-              <a:lnSpc>
-                <a:spcPct val="105000"/>
-              </a:lnSpc>
-              <a:buNone/>
-            </a:pPr>
-            <a:r>
-              <a:rPr lang="en-US" sz="1400" dirty="0">
-                <a:solidFill>
-                  <a:srgbClr val="1E2A36"/>
-                </a:solidFill>
-                <a:latin typeface="Calibri" pitchFamily="34" charset="0"/>
-                <a:ea typeface="Calibri" pitchFamily="34" charset="-122"/>
-                <a:cs typeface="Calibri" pitchFamily="34" charset="-120"/>
-              </a:rPr>
-              <a:t>r/byu threads · a parking-app review · my observation.    </a:t>
-            </a:r>
-            <a:pPr indent="0" marL="0">
-              <a:lnSpc>
-                <a:spcPct val="105000"/>
-              </a:lnSpc>
-              <a:buNone/>
-            </a:pPr>
-            <a:r>
-              <a:rPr lang="en-US" sz="1400" b="1" dirty="0">
-                <a:solidFill>
-                  <a:srgbClr val="0E6E6D"/>
-                </a:solidFill>
-                <a:latin typeface="Calibri" pitchFamily="34" charset="0"/>
-                <a:ea typeface="Calibri" pitchFamily="34" charset="-122"/>
-                <a:cs typeface="Calibri" pitchFamily="34" charset="-120"/>
-              </a:rPr>
-              <a:t>To verify: </a:t>
-            </a:r>
-            <a:pPr indent="0" marL="0">
-              <a:lnSpc>
-                <a:spcPct val="105000"/>
-              </a:lnSpc>
-              <a:buNone/>
-            </a:pPr>
-            <a:r>
-              <a:rPr lang="en-US" sz="1400" dirty="0">
-                <a:solidFill>
-                  <a:srgbClr val="1E2A36"/>
-                </a:solidFill>
-                <a:latin typeface="Calibri" pitchFamily="34" charset="0"/>
-                <a:ea typeface="Calibri" pitchFamily="34" charset="-122"/>
-                <a:cs typeface="Calibri" pitchFamily="34" charset="-120"/>
-              </a:rPr>
-              <a:t>does it really cause late class? would real-time info change behavior?    </a:t>
-            </a:r>
-            <a:pPr indent="0" marL="0">
-              <a:lnSpc>
-                <a:spcPct val="105000"/>
-              </a:lnSpc>
-              <a:buNone/>
-            </a:pPr>
-            <a:r>
-              <a:rPr lang="en-US" sz="1400" b="1" dirty="0">
-                <a:solidFill>
-                  <a:srgbClr val="1E2A36"/>
-                </a:solidFill>
-                <a:latin typeface="Calibri" pitchFamily="34" charset="0"/>
-                <a:ea typeface="Calibri" pitchFamily="34" charset="-122"/>
-                <a:cs typeface="Calibri" pitchFamily="34" charset="-120"/>
-              </a:rPr>
-              <a:t>Confidence: medium.</a:t>
-            </a:r>
-            <a:endParaRPr lang="en-US" sz="1400" dirty="0"/>
-          </a:p>
-        </p:txBody>
-      </p:sp>
-      <p:sp>
-        <p:nvSpPr>
-          <p:cNvPr id="9" name="Text 7"/>
+              <a:rPr lang="en-US" sz="1550" dirty="0">
+                <a:solidFill>
+                  <a:srgbClr val="CFE0E9"/>
+                </a:solidFill>
+                <a:latin typeface="Calibri" pitchFamily="34" charset="0"/>
+                <a:ea typeface="Calibri" pitchFamily="34" charset="-122"/>
+                <a:cs typeface="Calibri" pitchFamily="34" charset="-120"/>
+              </a:rPr>
+              <a:t>Next are two attempts at that same persona — same topic on purpose, so the only difference is the method. As each appears, ask yourself: could I trust this? What here is real evidence, and what's just a guess?</a:t>
+            </a:r>
+            <a:endParaRPr lang="en-US" sz="1550" dirty="0"/>
+          </a:p>
+        </p:txBody>
+      </p:sp>
+      <p:sp>
+        <p:nvSpPr>
+          <p:cNvPr id="14" name="Text 10"/>
           <p:cNvSpPr/>
           <p:nvPr/>
         </p:nvSpPr>
@@ -3288,7 +3246,7 @@
       </p:sp>
       <p:sp>
         <p:nvSpPr>
-          <p:cNvPr id="10" name="Text 8"/>
+          <p:cNvPr id="15" name="Text 11"/>
           <p:cNvSpPr/>
           <p:nvPr/>
         </p:nvSpPr>
@@ -3410,7 +3368,7 @@
                 <a:ea typeface="Calibri" pitchFamily="34" charset="-122"/>
                 <a:cs typeface="Calibri" pitchFamily="34" charset="-120"/>
               </a:rPr>
-              <a:t>PERSONA EXAMPLE — MADE-UP</a:t>
+              <a:t>PERSONA EXAMPLE — HONEST</a:t>
             </a:r>
             <a:endParaRPr lang="en-US" sz="1400" dirty="0"/>
           </a:p>
@@ -3449,7 +3407,7 @@
                 <a:ea typeface="Cambria" pitchFamily="34" charset="-122"/>
                 <a:cs typeface="Cambria" pitchFamily="34" charset="-120"/>
               </a:rPr>
-              <a:t>"Busy Ben" — what NOT to do</a:t>
+              <a:t>"Commuter Cara" (evidence-tagged)</a:t>
             </a:r>
             <a:endParaRPr lang="en-US" sz="3100" dirty="0"/>
           </a:p>
@@ -3464,15 +3422,15 @@
         <p:spPr>
           <a:xfrm>
             <a:off x="548640" y="1874520"/>
-            <a:ext cx="11064240" cy="2103120"/>
+            <a:ext cx="11064240" cy="3063240"/>
           </a:xfrm>
           <a:prstGeom prst="roundRect">
             <a:avLst>
-              <a:gd name="adj" fmla="val 3913"/>
+              <a:gd name="adj" fmla="val 2687"/>
             </a:avLst>
           </a:prstGeom>
           <a:solidFill>
-            <a:srgbClr val="FBECE8"/>
+            <a:srgbClr val="EAF4EE"/>
           </a:solidFill>
           <a:ln/>
           <a:effectLst>
@@ -3493,7 +3451,7 @@
         <p:spPr>
           <a:xfrm>
             <a:off x="868680" y="2057400"/>
-            <a:ext cx="10424160" cy="1783080"/>
+            <a:ext cx="10424160" cy="2377440"/>
           </a:xfrm>
           <a:prstGeom prst="rect">
             <a:avLst/>
@@ -3507,12 +3465,12 @@
           <a:p>
             <a:pPr indent="0" marL="0">
               <a:lnSpc>
-                <a:spcPct val="110000"/>
+                <a:spcPct val="122000"/>
               </a:lnSpc>
               <a:buNone/>
             </a:pPr>
             <a:r>
-              <a:rPr lang="en-US" sz="1650" i="1" dirty="0">
+              <a:rPr lang="en-US" sz="1550" b="1" dirty="0">
                 <a:solidFill>
                   <a:srgbClr val="1E2A36"/>
                 </a:solidFill>
@@ -3520,9 +3478,166 @@
                 <a:ea typeface="Calibri" pitchFamily="34" charset="-122"/>
                 <a:cs typeface="Calibri" pitchFamily="34" charset="-120"/>
               </a:rPr>
-              <a:t>Ben is a 20-year-old sophomore in CS with a 3.8 GPA. He works 15 hours a week, loves productivity apps, and is always on the go. He can never find parking and wastes about an hour every single day circling the lots. He would definitely pay $10/month for an app that shows open spots in real time — and he'd tell all his friends.</a:t>
-            </a:r>
-            <a:endParaRPr lang="en-US" sz="1650" dirty="0"/>
+              <a:t>Who:  </a:t>
+            </a:r>
+            <a:pPr indent="0" marL="0">
+              <a:lnSpc>
+                <a:spcPct val="122000"/>
+              </a:lnSpc>
+              <a:buNone/>
+            </a:pPr>
+            <a:r>
+              <a:rPr lang="en-US" sz="1550" dirty="0">
+                <a:solidFill>
+                  <a:srgbClr val="1E2A36"/>
+                </a:solidFill>
+                <a:latin typeface="Calibri" pitchFamily="34" charset="0"/>
+                <a:ea typeface="Calibri" pitchFamily="34" charset="-122"/>
+                <a:cs typeface="Calibri" pitchFamily="34" charset="-120"/>
+              </a:rPr>
+              <a:t>[E] off-campus student who drives to campus (r/byu threads; my lot observation).  [A] likely a soph/junior with a job.
+</a:t>
+            </a:r>
+            <a:pPr indent="0" marL="0">
+              <a:lnSpc>
+                <a:spcPct val="122000"/>
+              </a:lnSpc>
+              <a:buNone/>
+            </a:pPr>
+            <a:r>
+              <a:rPr lang="en-US" sz="1550" b="1" dirty="0">
+                <a:solidFill>
+                  <a:srgbClr val="1E2A36"/>
+                </a:solidFill>
+                <a:latin typeface="Calibri" pitchFamily="34" charset="0"/>
+                <a:ea typeface="Calibri" pitchFamily="34" charset="-122"/>
+                <a:cs typeface="Calibri" pitchFamily="34" charset="-120"/>
+              </a:rPr>
+              <a:t>Problem:  </a:t>
+            </a:r>
+            <a:pPr indent="0" marL="0">
+              <a:lnSpc>
+                <a:spcPct val="122000"/>
+              </a:lnSpc>
+              <a:buNone/>
+            </a:pPr>
+            <a:r>
+              <a:rPr lang="en-US" sz="1550" dirty="0">
+                <a:solidFill>
+                  <a:srgbClr val="1E2A36"/>
+                </a:solidFill>
+                <a:latin typeface="Calibri" pitchFamily="34" charset="0"/>
+                <a:ea typeface="Calibri" pitchFamily="34" charset="-122"/>
+                <a:cs typeface="Calibri" pitchFamily="34" charset="-120"/>
+              </a:rPr>
+              <a:t>[E] a mid-morning spot is unpredictable and eats time (forum posts; a friend).  [A] makes her late to class.
+</a:t>
+            </a:r>
+            <a:pPr indent="0" marL="0">
+              <a:lnSpc>
+                <a:spcPct val="122000"/>
+              </a:lnSpc>
+              <a:buNone/>
+            </a:pPr>
+            <a:r>
+              <a:rPr lang="en-US" sz="1550" b="1" dirty="0">
+                <a:solidFill>
+                  <a:srgbClr val="1E2A36"/>
+                </a:solidFill>
+                <a:latin typeface="Calibri" pitchFamily="34" charset="0"/>
+                <a:ea typeface="Calibri" pitchFamily="34" charset="-122"/>
+                <a:cs typeface="Calibri" pitchFamily="34" charset="-120"/>
+              </a:rPr>
+              <a:t>Today:  </a:t>
+            </a:r>
+            <a:pPr indent="0" marL="0">
+              <a:lnSpc>
+                <a:spcPct val="122000"/>
+              </a:lnSpc>
+              <a:buNone/>
+            </a:pPr>
+            <a:r>
+              <a:rPr lang="en-US" sz="1550" dirty="0">
+                <a:solidFill>
+                  <a:srgbClr val="1E2A36"/>
+                </a:solidFill>
+                <a:latin typeface="Calibri" pitchFamily="34" charset="0"/>
+                <a:ea typeface="Calibri" pitchFamily="34" charset="-122"/>
+                <a:cs typeface="Calibri" pitchFamily="34" charset="-120"/>
+              </a:rPr>
+              <a:t>[E] arrives 30–45 min early to "camp," or circles the lot.
+</a:t>
+            </a:r>
+            <a:pPr indent="0" marL="0">
+              <a:lnSpc>
+                <a:spcPct val="122000"/>
+              </a:lnSpc>
+              <a:buNone/>
+            </a:pPr>
+            <a:r>
+              <a:rPr lang="en-US" sz="1550" b="1" dirty="0">
+                <a:solidFill>
+                  <a:srgbClr val="1E2A36"/>
+                </a:solidFill>
+                <a:latin typeface="Calibri" pitchFamily="34" charset="0"/>
+                <a:ea typeface="Calibri" pitchFamily="34" charset="-122"/>
+                <a:cs typeface="Calibri" pitchFamily="34" charset="-120"/>
+              </a:rPr>
+              <a:t>Costs:  </a:t>
+            </a:r>
+            <a:pPr indent="0" marL="0">
+              <a:lnSpc>
+                <a:spcPct val="122000"/>
+              </a:lnSpc>
+              <a:buNone/>
+            </a:pPr>
+            <a:r>
+              <a:rPr lang="en-US" sz="1550" dirty="0">
+                <a:solidFill>
+                  <a:srgbClr val="1E2A36"/>
+                </a:solidFill>
+                <a:latin typeface="Calibri" pitchFamily="34" charset="0"/>
+                <a:ea typeface="Calibri" pitchFamily="34" charset="-122"/>
+                <a:cs typeface="Calibri" pitchFamily="34" charset="-120"/>
+              </a:rPr>
+              <a:t>[E] ~30 min/day + real frustration.
+</a:t>
+            </a:r>
+            <a:pPr indent="0" marL="0">
+              <a:lnSpc>
+                <a:spcPct val="122000"/>
+              </a:lnSpc>
+              <a:buNone/>
+            </a:pPr>
+            <a:r>
+              <a:rPr lang="en-US" sz="1550" b="1" dirty="0">
+                <a:solidFill>
+                  <a:srgbClr val="1E2A36"/>
+                </a:solidFill>
+                <a:latin typeface="Calibri" pitchFamily="34" charset="0"/>
+                <a:ea typeface="Calibri" pitchFamily="34" charset="-122"/>
+                <a:cs typeface="Calibri" pitchFamily="34" charset="-120"/>
+              </a:rPr>
+              <a:t>"Better":  </a:t>
+            </a:r>
+            <a:pPr indent="0" marL="0">
+              <a:lnSpc>
+                <a:spcPct val="122000"/>
+              </a:lnSpc>
+              <a:buNone/>
+            </a:pPr>
+            <a:r>
+              <a:rPr lang="en-US" sz="1550" dirty="0">
+                <a:solidFill>
+                  <a:srgbClr val="1E2A36"/>
+                </a:solidFill>
+                <a:latin typeface="Calibri" pitchFamily="34" charset="0"/>
+                <a:ea typeface="Calibri" pitchFamily="34" charset="-122"/>
+                <a:cs typeface="Calibri" pitchFamily="34" charset="-120"/>
+              </a:rPr>
+              <a:t>[A] real-time spot availability — my hypothesis, not a user's.</a:t>
+            </a:r>
+            <a:endParaRPr lang="en-US" sz="1550" dirty="0"/>
           </a:p>
         </p:txBody>
       </p:sp>
@@ -3534,16 +3649,16 @@
         </p:nvSpPr>
         <p:spPr>
           <a:xfrm>
-            <a:off x="548640" y="4160520"/>
-            <a:ext cx="11064240" cy="1828800"/>
+            <a:off x="548640" y="5074920"/>
+            <a:ext cx="11064240" cy="914400"/>
           </a:xfrm>
           <a:prstGeom prst="roundRect">
             <a:avLst>
-              <a:gd name="adj" fmla="val 4500"/>
+              <a:gd name="adj" fmla="val 9000"/>
             </a:avLst>
           </a:prstGeom>
           <a:solidFill>
-            <a:srgbClr val="14233A"/>
+            <a:srgbClr val="F2F6F8"/>
           </a:solidFill>
           <a:ln/>
           <a:effectLst>
@@ -3557,58 +3672,14 @@
       </p:sp>
       <p:sp>
         <p:nvSpPr>
-          <p:cNvPr id="8" name="Shape 6"/>
-          <p:cNvSpPr/>
-          <p:nvPr/>
-        </p:nvSpPr>
-        <p:spPr>
-          <a:xfrm>
-            <a:off x="868680" y="4480560"/>
-            <a:ext cx="566928" cy="566928"/>
-          </a:xfrm>
-          <a:prstGeom prst="ellipse">
-            <a:avLst/>
-          </a:prstGeom>
-          <a:solidFill>
-            <a:srgbClr val="E8A33D"/>
-          </a:solidFill>
-          <a:ln/>
-        </p:spPr>
-      </p:sp>
-      <p:pic>
-        <p:nvPicPr>
-          <p:cNvPr id="9" name="Image 0" descr="preencoded.png">    </p:cNvPr>
-          <p:cNvPicPr>
-            <a:picLocks noChangeAspect="1"/>
-          </p:cNvPicPr>
-          <p:nvPr/>
-        </p:nvPicPr>
-        <p:blipFill>
-          <a:blip r:embed="rId1"/>
-          <a:stretch>
-            <a:fillRect/>
-          </a:stretch>
-        </p:blipFill>
-        <p:spPr>
-          <a:xfrm>
-            <a:off x="1021751" y="4633631"/>
-            <a:ext cx="260787" cy="260787"/>
-          </a:xfrm>
-          <a:prstGeom prst="rect">
-            <a:avLst/>
-          </a:prstGeom>
-        </p:spPr>
-      </p:pic>
-      <p:sp>
-        <p:nvSpPr>
-          <p:cNvPr id="10" name="Text 7"/>
-          <p:cNvSpPr/>
-          <p:nvPr/>
-        </p:nvSpPr>
-        <p:spPr>
-          <a:xfrm>
-            <a:off x="1737360" y="4160520"/>
-            <a:ext cx="9601200" cy="1828800"/>
+          <p:cNvPr id="8" name="Text 6"/>
+          <p:cNvSpPr/>
+          <p:nvPr/>
+        </p:nvSpPr>
+        <p:spPr>
+          <a:xfrm>
+            <a:off x="868680" y="5074920"/>
+            <a:ext cx="10424160" cy="914400"/>
           </a:xfrm>
           <a:prstGeom prst="rect">
             <a:avLst/>
@@ -3622,45 +3693,96 @@
           <a:p>
             <a:pPr indent="0" marL="0">
               <a:lnSpc>
-                <a:spcPct val="106000"/>
+                <a:spcPct val="105000"/>
               </a:lnSpc>
               <a:buNone/>
             </a:pPr>
             <a:r>
-              <a:rPr lang="en-US" sz="1600" b="1" dirty="0">
-                <a:solidFill>
-                  <a:srgbClr val="E8A33D"/>
-                </a:solidFill>
-                <a:latin typeface="Calibri" pitchFamily="34" charset="0"/>
-                <a:ea typeface="Calibri" pitchFamily="34" charset="-122"/>
-                <a:cs typeface="Calibri" pitchFamily="34" charset="-120"/>
-              </a:rPr>
-              <a:t>Feels done. It's fiction.  </a:t>
+              <a:rPr lang="en-US" sz="1400" b="1" dirty="0">
+                <a:solidFill>
+                  <a:srgbClr val="0E6E6D"/>
+                </a:solidFill>
+                <a:latin typeface="Calibri" pitchFamily="34" charset="0"/>
+                <a:ea typeface="Calibri" pitchFamily="34" charset="-122"/>
+                <a:cs typeface="Calibri" pitchFamily="34" charset="-120"/>
+              </a:rPr>
+              <a:t>Sources: </a:t>
             </a:r>
             <a:pPr indent="0" marL="0">
               <a:lnSpc>
-                <a:spcPct val="106000"/>
+                <a:spcPct val="105000"/>
               </a:lnSpc>
               <a:buNone/>
             </a:pPr>
             <a:r>
-              <a:rPr lang="en-US" sz="1600" dirty="0">
-                <a:solidFill>
-                  <a:srgbClr val="FFFFFF"/>
-                </a:solidFill>
-                <a:latin typeface="Calibri" pitchFamily="34" charset="0"/>
-                <a:ea typeface="Calibri" pitchFamily="34" charset="-122"/>
-                <a:cs typeface="Calibri" pitchFamily="34" charset="-120"/>
-              </a:rPr>
-              <a:t>Every detail is invented and unsourced (the GPA, "an hour every day"). Nothing is marked as a guess. And "would definitely pay $10/month" is a hypothetical dressed up as a fact — the exact Mom Test trap. A founder who builds on Ben builds confidently on fiction.</a:t>
-            </a:r>
-            <a:endParaRPr lang="en-US" sz="1600" dirty="0"/>
-          </a:p>
-        </p:txBody>
-      </p:sp>
-      <p:sp>
-        <p:nvSpPr>
-          <p:cNvPr id="11" name="Text 8"/>
+              <a:rPr lang="en-US" sz="1400" dirty="0">
+                <a:solidFill>
+                  <a:srgbClr val="1E2A36"/>
+                </a:solidFill>
+                <a:latin typeface="Calibri" pitchFamily="34" charset="0"/>
+                <a:ea typeface="Calibri" pitchFamily="34" charset="-122"/>
+                <a:cs typeface="Calibri" pitchFamily="34" charset="-120"/>
+              </a:rPr>
+              <a:t>r/byu threads · a parking-app review · my observation.    </a:t>
+            </a:r>
+            <a:pPr indent="0" marL="0">
+              <a:lnSpc>
+                <a:spcPct val="105000"/>
+              </a:lnSpc>
+              <a:buNone/>
+            </a:pPr>
+            <a:r>
+              <a:rPr lang="en-US" sz="1400" b="1" dirty="0">
+                <a:solidFill>
+                  <a:srgbClr val="0E6E6D"/>
+                </a:solidFill>
+                <a:latin typeface="Calibri" pitchFamily="34" charset="0"/>
+                <a:ea typeface="Calibri" pitchFamily="34" charset="-122"/>
+                <a:cs typeface="Calibri" pitchFamily="34" charset="-120"/>
+              </a:rPr>
+              <a:t>To verify: </a:t>
+            </a:r>
+            <a:pPr indent="0" marL="0">
+              <a:lnSpc>
+                <a:spcPct val="105000"/>
+              </a:lnSpc>
+              <a:buNone/>
+            </a:pPr>
+            <a:r>
+              <a:rPr lang="en-US" sz="1400" dirty="0">
+                <a:solidFill>
+                  <a:srgbClr val="1E2A36"/>
+                </a:solidFill>
+                <a:latin typeface="Calibri" pitchFamily="34" charset="0"/>
+                <a:ea typeface="Calibri" pitchFamily="34" charset="-122"/>
+                <a:cs typeface="Calibri" pitchFamily="34" charset="-120"/>
+              </a:rPr>
+              <a:t>does it really cause late class? would real-time info change behavior?    </a:t>
+            </a:r>
+            <a:pPr indent="0" marL="0">
+              <a:lnSpc>
+                <a:spcPct val="105000"/>
+              </a:lnSpc>
+              <a:buNone/>
+            </a:pPr>
+            <a:r>
+              <a:rPr lang="en-US" sz="1400" b="1" dirty="0">
+                <a:solidFill>
+                  <a:srgbClr val="1E2A36"/>
+                </a:solidFill>
+                <a:latin typeface="Calibri" pitchFamily="34" charset="0"/>
+                <a:ea typeface="Calibri" pitchFamily="34" charset="-122"/>
+                <a:cs typeface="Calibri" pitchFamily="34" charset="-120"/>
+              </a:rPr>
+              <a:t>Confidence: medium.</a:t>
+            </a:r>
+            <a:endParaRPr lang="en-US" sz="1400" dirty="0"/>
+          </a:p>
+        </p:txBody>
+      </p:sp>
+      <p:sp>
+        <p:nvSpPr>
+          <p:cNvPr id="9" name="Text 7"/>
           <p:cNvSpPr/>
           <p:nvPr/>
         </p:nvSpPr>
@@ -3699,7 +3821,7 @@
       </p:sp>
       <p:sp>
         <p:nvSpPr>
-          <p:cNvPr id="12" name="Text 9"/>
+          <p:cNvPr id="10" name="Text 8"/>
           <p:cNvSpPr/>
           <p:nvPr/>
         </p:nvSpPr>
@@ -3747,6 +3869,417 @@
 <file path=ppt/slides/slide13.xml><?xml version="1.0" encoding="utf-8"?>
 <p:sld xmlns:a="http://schemas.openxmlformats.org/drawingml/2006/main" xmlns:r="http://schemas.openxmlformats.org/officeDocument/2006/relationships" xmlns:p="http://schemas.openxmlformats.org/presentationml/2006/main">
   <p:cSld name="Slide 13">
+    <p:bg>
+      <p:bgPr>
+        <a:solidFill>
+          <a:srgbClr val="FFFFFF"/>
+        </a:solidFill>
+      </p:bgPr>
+    </p:bg>
+    <p:spTree>
+      <p:nvGrpSpPr>
+        <p:cNvPr id="1" name=""/>
+        <p:cNvGrpSpPr/>
+        <p:nvPr/>
+      </p:nvGrpSpPr>
+      <p:grpSpPr>
+        <a:xfrm>
+          <a:off x="0" y="0"/>
+          <a:ext cx="0" cy="0"/>
+          <a:chOff x="0" y="0"/>
+          <a:chExt cx="0" cy="0"/>
+        </a:xfrm>
+      </p:grpSpPr>
+      <p:sp>
+        <p:nvSpPr>
+          <p:cNvPr id="2" name="Shape 0"/>
+          <p:cNvSpPr/>
+          <p:nvPr/>
+        </p:nvSpPr>
+        <p:spPr>
+          <a:xfrm>
+            <a:off x="566928" y="502920"/>
+            <a:ext cx="137160" cy="137160"/>
+          </a:xfrm>
+          <a:prstGeom prst="ellipse">
+            <a:avLst/>
+          </a:prstGeom>
+          <a:solidFill>
+            <a:srgbClr val="E8A33D"/>
+          </a:solidFill>
+          <a:ln/>
+        </p:spPr>
+      </p:sp>
+      <p:sp>
+        <p:nvSpPr>
+          <p:cNvPr id="3" name="Text 1"/>
+          <p:cNvSpPr/>
+          <p:nvPr/>
+        </p:nvSpPr>
+        <p:spPr>
+          <a:xfrm>
+            <a:off x="795528" y="402336"/>
+            <a:ext cx="10515600" cy="310896"/>
+          </a:xfrm>
+          <a:prstGeom prst="rect">
+            <a:avLst/>
+          </a:prstGeom>
+          <a:noFill/>
+          <a:ln/>
+        </p:spPr>
+        <p:txBody>
+          <a:bodyPr wrap="square" lIns="0" tIns="0" rIns="0" bIns="0" rtlCol="0" anchor="ctr"/>
+          <a:lstStyle/>
+          <a:p>
+            <a:pPr indent="0" marL="0">
+              <a:buNone/>
+            </a:pPr>
+            <a:r>
+              <a:rPr lang="en-US" sz="1400" b="1" spc="200" kern="0" dirty="0">
+                <a:solidFill>
+                  <a:srgbClr val="12908F"/>
+                </a:solidFill>
+                <a:latin typeface="Calibri" pitchFamily="34" charset="0"/>
+                <a:ea typeface="Calibri" pitchFamily="34" charset="-122"/>
+                <a:cs typeface="Calibri" pitchFamily="34" charset="-120"/>
+              </a:rPr>
+              <a:t>PERSONA EXAMPLE — MADE-UP</a:t>
+            </a:r>
+            <a:endParaRPr lang="en-US" sz="1400" dirty="0"/>
+          </a:p>
+        </p:txBody>
+      </p:sp>
+      <p:sp>
+        <p:nvSpPr>
+          <p:cNvPr id="4" name="Text 2"/>
+          <p:cNvSpPr/>
+          <p:nvPr/>
+        </p:nvSpPr>
+        <p:spPr>
+          <a:xfrm>
+            <a:off x="548640" y="749808"/>
+            <a:ext cx="11064240" cy="914400"/>
+          </a:xfrm>
+          <a:prstGeom prst="rect">
+            <a:avLst/>
+          </a:prstGeom>
+          <a:noFill/>
+          <a:ln/>
+        </p:spPr>
+        <p:txBody>
+          <a:bodyPr wrap="square" lIns="0" tIns="0" rIns="0" bIns="0" rtlCol="0" anchor="t"/>
+          <a:lstStyle/>
+          <a:p>
+            <a:pPr indent="0" marL="0">
+              <a:buNone/>
+            </a:pPr>
+            <a:r>
+              <a:rPr lang="en-US" sz="3100" b="1" dirty="0">
+                <a:solidFill>
+                  <a:srgbClr val="1E2A36"/>
+                </a:solidFill>
+                <a:latin typeface="Cambria" pitchFamily="34" charset="0"/>
+                <a:ea typeface="Cambria" pitchFamily="34" charset="-122"/>
+                <a:cs typeface="Cambria" pitchFamily="34" charset="-120"/>
+              </a:rPr>
+              <a:t>"Busy Ben" — what NOT to do</a:t>
+            </a:r>
+            <a:endParaRPr lang="en-US" sz="3100" dirty="0"/>
+          </a:p>
+        </p:txBody>
+      </p:sp>
+      <p:sp>
+        <p:nvSpPr>
+          <p:cNvPr id="5" name="Shape 3"/>
+          <p:cNvSpPr/>
+          <p:nvPr/>
+        </p:nvSpPr>
+        <p:spPr>
+          <a:xfrm>
+            <a:off x="548640" y="1874520"/>
+            <a:ext cx="11064240" cy="2103120"/>
+          </a:xfrm>
+          <a:prstGeom prst="roundRect">
+            <a:avLst>
+              <a:gd name="adj" fmla="val 3913"/>
+            </a:avLst>
+          </a:prstGeom>
+          <a:solidFill>
+            <a:srgbClr val="FBECE8"/>
+          </a:solidFill>
+          <a:ln/>
+          <a:effectLst>
+            <a:outerShdw sx="100000" sy="100000" kx="0" ky="0" algn="bl" rotWithShape="0" blurRad="88900" dist="38100" dir="5400000">
+              <a:srgbClr val="000000">
+                <a:alpha val="13000"/>
+              </a:srgbClr>
+            </a:outerShdw>
+          </a:effectLst>
+        </p:spPr>
+      </p:sp>
+      <p:sp>
+        <p:nvSpPr>
+          <p:cNvPr id="6" name="Text 4"/>
+          <p:cNvSpPr/>
+          <p:nvPr/>
+        </p:nvSpPr>
+        <p:spPr>
+          <a:xfrm>
+            <a:off x="868680" y="2057400"/>
+            <a:ext cx="10424160" cy="1783080"/>
+          </a:xfrm>
+          <a:prstGeom prst="rect">
+            <a:avLst/>
+          </a:prstGeom>
+          <a:noFill/>
+          <a:ln/>
+        </p:spPr>
+        <p:txBody>
+          <a:bodyPr wrap="square" lIns="0" tIns="0" rIns="0" bIns="0" rtlCol="0" anchor="t"/>
+          <a:lstStyle/>
+          <a:p>
+            <a:pPr indent="0" marL="0">
+              <a:lnSpc>
+                <a:spcPct val="110000"/>
+              </a:lnSpc>
+              <a:buNone/>
+            </a:pPr>
+            <a:r>
+              <a:rPr lang="en-US" sz="1650" i="1" dirty="0">
+                <a:solidFill>
+                  <a:srgbClr val="1E2A36"/>
+                </a:solidFill>
+                <a:latin typeface="Calibri" pitchFamily="34" charset="0"/>
+                <a:ea typeface="Calibri" pitchFamily="34" charset="-122"/>
+                <a:cs typeface="Calibri" pitchFamily="34" charset="-120"/>
+              </a:rPr>
+              <a:t>Ben is a 20-year-old sophomore in CS with a 3.8 GPA. He works 15 hours a week, loves productivity apps, and is always on the go. He can never find parking and wastes about an hour every single day circling the lots. He would definitely pay $10/month for an app that shows open spots in real time — and he'd tell all his friends.</a:t>
+            </a:r>
+            <a:endParaRPr lang="en-US" sz="1650" dirty="0"/>
+          </a:p>
+        </p:txBody>
+      </p:sp>
+      <p:sp>
+        <p:nvSpPr>
+          <p:cNvPr id="7" name="Shape 5"/>
+          <p:cNvSpPr/>
+          <p:nvPr/>
+        </p:nvSpPr>
+        <p:spPr>
+          <a:xfrm>
+            <a:off x="548640" y="4160520"/>
+            <a:ext cx="11064240" cy="1828800"/>
+          </a:xfrm>
+          <a:prstGeom prst="roundRect">
+            <a:avLst>
+              <a:gd name="adj" fmla="val 4500"/>
+            </a:avLst>
+          </a:prstGeom>
+          <a:solidFill>
+            <a:srgbClr val="14233A"/>
+          </a:solidFill>
+          <a:ln/>
+          <a:effectLst>
+            <a:outerShdw sx="100000" sy="100000" kx="0" ky="0" algn="bl" rotWithShape="0" blurRad="88900" dist="38100" dir="5400000">
+              <a:srgbClr val="000000">
+                <a:alpha val="13000"/>
+              </a:srgbClr>
+            </a:outerShdw>
+          </a:effectLst>
+        </p:spPr>
+      </p:sp>
+      <p:sp>
+        <p:nvSpPr>
+          <p:cNvPr id="8" name="Shape 6"/>
+          <p:cNvSpPr/>
+          <p:nvPr/>
+        </p:nvSpPr>
+        <p:spPr>
+          <a:xfrm>
+            <a:off x="868680" y="4480560"/>
+            <a:ext cx="566928" cy="566928"/>
+          </a:xfrm>
+          <a:prstGeom prst="ellipse">
+            <a:avLst/>
+          </a:prstGeom>
+          <a:solidFill>
+            <a:srgbClr val="E8A33D"/>
+          </a:solidFill>
+          <a:ln/>
+        </p:spPr>
+      </p:sp>
+      <p:pic>
+        <p:nvPicPr>
+          <p:cNvPr id="9" name="Image 0" descr="preencoded.png">    </p:cNvPr>
+          <p:cNvPicPr>
+            <a:picLocks noChangeAspect="1"/>
+          </p:cNvPicPr>
+          <p:nvPr/>
+        </p:nvPicPr>
+        <p:blipFill>
+          <a:blip r:embed="rId1"/>
+          <a:stretch>
+            <a:fillRect/>
+          </a:stretch>
+        </p:blipFill>
+        <p:spPr>
+          <a:xfrm>
+            <a:off x="1021751" y="4633631"/>
+            <a:ext cx="260787" cy="260787"/>
+          </a:xfrm>
+          <a:prstGeom prst="rect">
+            <a:avLst/>
+          </a:prstGeom>
+        </p:spPr>
+      </p:pic>
+      <p:sp>
+        <p:nvSpPr>
+          <p:cNvPr id="10" name="Text 7"/>
+          <p:cNvSpPr/>
+          <p:nvPr/>
+        </p:nvSpPr>
+        <p:spPr>
+          <a:xfrm>
+            <a:off x="1737360" y="4160520"/>
+            <a:ext cx="9601200" cy="1828800"/>
+          </a:xfrm>
+          <a:prstGeom prst="rect">
+            <a:avLst/>
+          </a:prstGeom>
+          <a:noFill/>
+          <a:ln/>
+        </p:spPr>
+        <p:txBody>
+          <a:bodyPr wrap="square" lIns="0" tIns="0" rIns="0" bIns="0" rtlCol="0" anchor="ctr"/>
+          <a:lstStyle/>
+          <a:p>
+            <a:pPr indent="0" marL="0">
+              <a:lnSpc>
+                <a:spcPct val="106000"/>
+              </a:lnSpc>
+              <a:buNone/>
+            </a:pPr>
+            <a:r>
+              <a:rPr lang="en-US" sz="1600" b="1" dirty="0">
+                <a:solidFill>
+                  <a:srgbClr val="E8A33D"/>
+                </a:solidFill>
+                <a:latin typeface="Calibri" pitchFamily="34" charset="0"/>
+                <a:ea typeface="Calibri" pitchFamily="34" charset="-122"/>
+                <a:cs typeface="Calibri" pitchFamily="34" charset="-120"/>
+              </a:rPr>
+              <a:t>Feels done. It's fiction.  </a:t>
+            </a:r>
+            <a:pPr indent="0" marL="0">
+              <a:lnSpc>
+                <a:spcPct val="106000"/>
+              </a:lnSpc>
+              <a:buNone/>
+            </a:pPr>
+            <a:r>
+              <a:rPr lang="en-US" sz="1600" dirty="0">
+                <a:solidFill>
+                  <a:srgbClr val="FFFFFF"/>
+                </a:solidFill>
+                <a:latin typeface="Calibri" pitchFamily="34" charset="0"/>
+                <a:ea typeface="Calibri" pitchFamily="34" charset="-122"/>
+                <a:cs typeface="Calibri" pitchFamily="34" charset="-120"/>
+              </a:rPr>
+              <a:t>Every detail is invented and unsourced (the GPA, "an hour every day"). Nothing is marked as a guess. And "would definitely pay $10/month" is a hypothetical dressed up as a fact — the exact Mom Test trap. A founder who builds on Ben builds confidently on fiction.</a:t>
+            </a:r>
+            <a:endParaRPr lang="en-US" sz="1600" dirty="0"/>
+          </a:p>
+        </p:txBody>
+      </p:sp>
+      <p:sp>
+        <p:nvSpPr>
+          <p:cNvPr id="11" name="Text 8"/>
+          <p:cNvSpPr/>
+          <p:nvPr/>
+        </p:nvSpPr>
+        <p:spPr>
+          <a:xfrm>
+            <a:off x="7132320" y="6437376"/>
+            <a:ext cx="4480560" cy="274320"/>
+          </a:xfrm>
+          <a:prstGeom prst="rect">
+            <a:avLst/>
+          </a:prstGeom>
+          <a:noFill/>
+          <a:ln/>
+        </p:spPr>
+        <p:txBody>
+          <a:bodyPr wrap="square" lIns="0" tIns="0" rIns="0" bIns="0" rtlCol="0" anchor="ctr"/>
+          <a:lstStyle/>
+          <a:p>
+            <a:pPr algn="r" indent="0" marL="0">
+              <a:buNone/>
+            </a:pPr>
+            <a:r>
+              <a:rPr lang="en-US" sz="1000" dirty="0">
+                <a:solidFill>
+                  <a:srgbClr val="5F7284"/>
+                </a:solidFill>
+                <a:latin typeface="Calibri" pitchFamily="34" charset="0"/>
+                <a:ea typeface="Calibri" pitchFamily="34" charset="-122"/>
+                <a:cs typeface="Calibri" pitchFamily="34" charset="-120"/>
+              </a:rPr>
+              <a:t>CS 301R · Session 4 · Discovery Workshop</a:t>
+            </a:r>
+            <a:endParaRPr lang="en-US" sz="1000" dirty="0"/>
+          </a:p>
+        </p:txBody>
+      </p:sp>
+      <p:sp>
+        <p:nvSpPr>
+          <p:cNvPr id="12" name="Text 9"/>
+          <p:cNvSpPr/>
+          <p:nvPr/>
+        </p:nvSpPr>
+        <p:spPr>
+          <a:xfrm>
+            <a:off x="548640" y="6437376"/>
+            <a:ext cx="548640" cy="274320"/>
+          </a:xfrm>
+          <a:prstGeom prst="rect">
+            <a:avLst/>
+          </a:prstGeom>
+          <a:noFill/>
+          <a:ln/>
+        </p:spPr>
+        <p:txBody>
+          <a:bodyPr wrap="square" lIns="0" tIns="0" rIns="0" bIns="0" rtlCol="0" anchor="ctr"/>
+          <a:lstStyle/>
+          <a:p>
+            <a:pPr indent="0" marL="0">
+              <a:buNone/>
+            </a:pPr>
+            <a:r>
+              <a:rPr lang="en-US" sz="1000" dirty="0">
+                <a:solidFill>
+                  <a:srgbClr val="5F7284"/>
+                </a:solidFill>
+                <a:latin typeface="Calibri" pitchFamily="34" charset="0"/>
+                <a:ea typeface="Calibri" pitchFamily="34" charset="-122"/>
+                <a:cs typeface="Calibri" pitchFamily="34" charset="-120"/>
+              </a:rPr>
+              <a:t>13</a:t>
+            </a:r>
+            <a:endParaRPr lang="en-US" sz="1000" dirty="0"/>
+          </a:p>
+        </p:txBody>
+      </p:sp>
+    </p:spTree>
+  </p:cSld>
+  <p:clrMapOvr>
+    <a:masterClrMapping/>
+  </p:clrMapOvr>
+</p:sld>
+</file>
+
+<file path=ppt/slides/slide14.xml><?xml version="1.0" encoding="utf-8"?>
+<p:sld xmlns:a="http://schemas.openxmlformats.org/drawingml/2006/main" xmlns:r="http://schemas.openxmlformats.org/officeDocument/2006/relationships" xmlns:p="http://schemas.openxmlformats.org/presentationml/2006/main">
+  <p:cSld name="Slide 14">
     <p:bg>
       <p:bgPr>
         <a:solidFill>
@@ -4128,9 +4661,9 @@
 </p:sld>
 </file>
 
-<file path=ppt/slides/slide14.xml><?xml version="1.0" encoding="utf-8"?>
+<file path=ppt/slides/slide15.xml><?xml version="1.0" encoding="utf-8"?>
 <p:sld xmlns:a="http://schemas.openxmlformats.org/drawingml/2006/main" xmlns:r="http://schemas.openxmlformats.org/officeDocument/2006/relationships" xmlns:p="http://schemas.openxmlformats.org/presentationml/2006/main">
-  <p:cSld name="Slide 14">
+  <p:cSld name="Slide 15">
     <p:bg>
       <p:bgPr>
         <a:solidFill>
@@ -8233,6 +8766,1062 @@
     <p:bg>
       <p:bgPr>
         <a:solidFill>
+          <a:srgbClr val="FFFFFF"/>
+        </a:solidFill>
+      </p:bgPr>
+    </p:bg>
+    <p:spTree>
+      <p:nvGrpSpPr>
+        <p:cNvPr id="1" name=""/>
+        <p:cNvGrpSpPr/>
+        <p:nvPr/>
+      </p:nvGrpSpPr>
+      <p:grpSpPr>
+        <a:xfrm>
+          <a:off x="0" y="0"/>
+          <a:ext cx="0" cy="0"/>
+          <a:chOff x="0" y="0"/>
+          <a:chExt cx="0" cy="0"/>
+        </a:xfrm>
+      </p:grpSpPr>
+      <p:sp>
+        <p:nvSpPr>
+          <p:cNvPr id="2" name="Shape 0"/>
+          <p:cNvSpPr/>
+          <p:nvPr/>
+        </p:nvSpPr>
+        <p:spPr>
+          <a:xfrm>
+            <a:off x="566928" y="502920"/>
+            <a:ext cx="137160" cy="137160"/>
+          </a:xfrm>
+          <a:prstGeom prst="ellipse">
+            <a:avLst/>
+          </a:prstGeom>
+          <a:solidFill>
+            <a:srgbClr val="E8A33D"/>
+          </a:solidFill>
+          <a:ln/>
+        </p:spPr>
+      </p:sp>
+      <p:sp>
+        <p:nvSpPr>
+          <p:cNvPr id="3" name="Text 1"/>
+          <p:cNvSpPr/>
+          <p:nvPr/>
+        </p:nvSpPr>
+        <p:spPr>
+          <a:xfrm>
+            <a:off x="795528" y="402336"/>
+            <a:ext cx="10515600" cy="310896"/>
+          </a:xfrm>
+          <a:prstGeom prst="rect">
+            <a:avLst/>
+          </a:prstGeom>
+          <a:noFill/>
+          <a:ln/>
+        </p:spPr>
+        <p:txBody>
+          <a:bodyPr wrap="square" lIns="0" tIns="0" rIns="0" bIns="0" rtlCol="0" anchor="ctr"/>
+          <a:lstStyle/>
+          <a:p>
+            <a:pPr indent="0" marL="0">
+              <a:buNone/>
+            </a:pPr>
+            <a:r>
+              <a:rPr lang="en-US" sz="1400" b="1" spc="200" kern="0" dirty="0">
+                <a:solidFill>
+                  <a:srgbClr val="12908F"/>
+                </a:solidFill>
+                <a:latin typeface="Calibri" pitchFamily="34" charset="0"/>
+                <a:ea typeface="Calibri" pitchFamily="34" charset="-122"/>
+                <a:cs typeface="Calibri" pitchFamily="34" charset="-120"/>
+              </a:rPr>
+              <a:t>BEFORE YOU INTERVIEW A REAL PERSON</a:t>
+            </a:r>
+            <a:endParaRPr lang="en-US" sz="1400" dirty="0"/>
+          </a:p>
+        </p:txBody>
+      </p:sp>
+      <p:sp>
+        <p:nvSpPr>
+          <p:cNvPr id="4" name="Text 2"/>
+          <p:cNvSpPr/>
+          <p:nvPr/>
+        </p:nvSpPr>
+        <p:spPr>
+          <a:xfrm>
+            <a:off x="548640" y="749808"/>
+            <a:ext cx="11064240" cy="914400"/>
+          </a:xfrm>
+          <a:prstGeom prst="rect">
+            <a:avLst/>
+          </a:prstGeom>
+          <a:noFill/>
+          <a:ln/>
+        </p:spPr>
+        <p:txBody>
+          <a:bodyPr wrap="square" lIns="0" tIns="0" rIns="0" bIns="0" rtlCol="0" anchor="t"/>
+          <a:lstStyle/>
+          <a:p>
+            <a:pPr indent="0" marL="0">
+              <a:buNone/>
+            </a:pPr>
+            <a:r>
+              <a:rPr lang="en-US" sz="3100" b="1" dirty="0">
+                <a:solidFill>
+                  <a:srgbClr val="1E2A36"/>
+                </a:solidFill>
+                <a:latin typeface="Cambria" pitchFamily="34" charset="0"/>
+                <a:ea typeface="Cambria" pitchFamily="34" charset="-122"/>
+                <a:cs typeface="Cambria" pitchFamily="34" charset="-120"/>
+              </a:rPr>
+              <a:t>Four things you confirm — hands up</a:t>
+            </a:r>
+            <a:endParaRPr lang="en-US" sz="3100" dirty="0"/>
+          </a:p>
+        </p:txBody>
+      </p:sp>
+      <p:sp>
+        <p:nvSpPr>
+          <p:cNvPr id="5" name="Shape 3"/>
+          <p:cNvSpPr/>
+          <p:nvPr/>
+        </p:nvSpPr>
+        <p:spPr>
+          <a:xfrm>
+            <a:off x="548640" y="1737360"/>
+            <a:ext cx="2670048" cy="2148840"/>
+          </a:xfrm>
+          <a:prstGeom prst="roundRect">
+            <a:avLst>
+              <a:gd name="adj" fmla="val 3830"/>
+            </a:avLst>
+          </a:prstGeom>
+          <a:solidFill>
+            <a:srgbClr val="F2F6F8"/>
+          </a:solidFill>
+          <a:ln/>
+          <a:effectLst>
+            <a:outerShdw sx="100000" sy="100000" kx="0" ky="0" algn="bl" rotWithShape="0" blurRad="88900" dist="38100" dir="5400000">
+              <a:srgbClr val="000000">
+                <a:alpha val="13000"/>
+              </a:srgbClr>
+            </a:outerShdw>
+          </a:effectLst>
+        </p:spPr>
+      </p:sp>
+      <p:sp>
+        <p:nvSpPr>
+          <p:cNvPr id="6" name="Shape 4"/>
+          <p:cNvSpPr/>
+          <p:nvPr/>
+        </p:nvSpPr>
+        <p:spPr>
+          <a:xfrm>
+            <a:off x="1581912" y="1956816"/>
+            <a:ext cx="603504" cy="603504"/>
+          </a:xfrm>
+          <a:prstGeom prst="ellipse">
+            <a:avLst/>
+          </a:prstGeom>
+          <a:solidFill>
+            <a:srgbClr val="12908F"/>
+          </a:solidFill>
+          <a:ln/>
+        </p:spPr>
+      </p:sp>
+      <p:pic>
+        <p:nvPicPr>
+          <p:cNvPr id="7" name="Image 0" descr="preencoded.png">    </p:cNvPr>
+          <p:cNvPicPr>
+            <a:picLocks noChangeAspect="1"/>
+          </p:cNvPicPr>
+          <p:nvPr/>
+        </p:nvPicPr>
+        <p:blipFill>
+          <a:blip r:embed="rId1"/>
+          <a:stretch>
+            <a:fillRect/>
+          </a:stretch>
+        </p:blipFill>
+        <p:spPr>
+          <a:xfrm>
+            <a:off x="1744858" y="2119762"/>
+            <a:ext cx="277612" cy="277612"/>
+          </a:xfrm>
+          <a:prstGeom prst="rect">
+            <a:avLst/>
+          </a:prstGeom>
+        </p:spPr>
+      </p:pic>
+      <p:sp>
+        <p:nvSpPr>
+          <p:cNvPr id="8" name="Text 5"/>
+          <p:cNvSpPr/>
+          <p:nvPr/>
+        </p:nvSpPr>
+        <p:spPr>
+          <a:xfrm>
+            <a:off x="694944" y="2688336"/>
+            <a:ext cx="2377440" cy="548640"/>
+          </a:xfrm>
+          <a:prstGeom prst="rect">
+            <a:avLst/>
+          </a:prstGeom>
+          <a:noFill/>
+          <a:ln/>
+        </p:spPr>
+        <p:txBody>
+          <a:bodyPr wrap="square" lIns="0" tIns="0" rIns="0" bIns="0" rtlCol="0" anchor="ctr"/>
+          <a:lstStyle/>
+          <a:p>
+            <a:pPr algn="ctr" indent="0" marL="0">
+              <a:lnSpc>
+                <a:spcPct val="100000"/>
+              </a:lnSpc>
+              <a:buNone/>
+            </a:pPr>
+            <a:r>
+              <a:rPr lang="en-US" sz="1600" b="1" dirty="0">
+                <a:solidFill>
+                  <a:srgbClr val="1E2A36"/>
+                </a:solidFill>
+                <a:latin typeface="Calibri" pitchFamily="34" charset="0"/>
+                <a:ea typeface="Calibri" pitchFamily="34" charset="-122"/>
+                <a:cs typeface="Calibri" pitchFamily="34" charset="-120"/>
+              </a:rPr>
+              <a:t>Ask, and say why</a:t>
+            </a:r>
+            <a:endParaRPr lang="en-US" sz="1600" dirty="0"/>
+          </a:p>
+        </p:txBody>
+      </p:sp>
+      <p:sp>
+        <p:nvSpPr>
+          <p:cNvPr id="9" name="Text 6"/>
+          <p:cNvSpPr/>
+          <p:nvPr/>
+        </p:nvSpPr>
+        <p:spPr>
+          <a:xfrm>
+            <a:off x="731520" y="3255264"/>
+            <a:ext cx="2304288" cy="548640"/>
+          </a:xfrm>
+          <a:prstGeom prst="rect">
+            <a:avLst/>
+          </a:prstGeom>
+          <a:noFill/>
+          <a:ln/>
+        </p:spPr>
+        <p:txBody>
+          <a:bodyPr wrap="square" lIns="0" tIns="0" rIns="0" bIns="0" rtlCol="0" anchor="t"/>
+          <a:lstStyle/>
+          <a:p>
+            <a:pPr algn="ctr" indent="0" marL="0">
+              <a:lnSpc>
+                <a:spcPct val="104000"/>
+              </a:lnSpc>
+              <a:buNone/>
+            </a:pPr>
+            <a:r>
+              <a:rPr lang="en-US" sz="1300" dirty="0">
+                <a:solidFill>
+                  <a:srgbClr val="5F7284"/>
+                </a:solidFill>
+                <a:latin typeface="Calibri" pitchFamily="34" charset="0"/>
+                <a:ea typeface="Calibri" pitchFamily="34" charset="-122"/>
+                <a:cs typeface="Calibri" pitchFamily="34" charset="-120"/>
+              </a:rPr>
+              <a:t>Who you are, what you're learning, how long it takes.</a:t>
+            </a:r>
+            <a:endParaRPr lang="en-US" sz="1300" dirty="0"/>
+          </a:p>
+        </p:txBody>
+      </p:sp>
+      <p:sp>
+        <p:nvSpPr>
+          <p:cNvPr id="10" name="Shape 7"/>
+          <p:cNvSpPr/>
+          <p:nvPr/>
+        </p:nvSpPr>
+        <p:spPr>
+          <a:xfrm>
+            <a:off x="3364992" y="1737360"/>
+            <a:ext cx="2670048" cy="2148840"/>
+          </a:xfrm>
+          <a:prstGeom prst="roundRect">
+            <a:avLst>
+              <a:gd name="adj" fmla="val 3830"/>
+            </a:avLst>
+          </a:prstGeom>
+          <a:solidFill>
+            <a:srgbClr val="F2F6F8"/>
+          </a:solidFill>
+          <a:ln/>
+          <a:effectLst>
+            <a:outerShdw sx="100000" sy="100000" kx="0" ky="0" algn="bl" rotWithShape="0" blurRad="88900" dist="38100" dir="5400000">
+              <a:srgbClr val="000000">
+                <a:alpha val="13000"/>
+              </a:srgbClr>
+            </a:outerShdw>
+          </a:effectLst>
+        </p:spPr>
+      </p:sp>
+      <p:sp>
+        <p:nvSpPr>
+          <p:cNvPr id="11" name="Shape 8"/>
+          <p:cNvSpPr/>
+          <p:nvPr/>
+        </p:nvSpPr>
+        <p:spPr>
+          <a:xfrm>
+            <a:off x="4398264" y="1956816"/>
+            <a:ext cx="603504" cy="603504"/>
+          </a:xfrm>
+          <a:prstGeom prst="ellipse">
+            <a:avLst/>
+          </a:prstGeom>
+          <a:solidFill>
+            <a:srgbClr val="12908F"/>
+          </a:solidFill>
+          <a:ln/>
+        </p:spPr>
+      </p:sp>
+      <p:pic>
+        <p:nvPicPr>
+          <p:cNvPr id="12" name="Image 1" descr="preencoded.png">    </p:cNvPr>
+          <p:cNvPicPr>
+            <a:picLocks noChangeAspect="1"/>
+          </p:cNvPicPr>
+          <p:nvPr/>
+        </p:nvPicPr>
+        <p:blipFill>
+          <a:blip r:embed="rId2"/>
+          <a:stretch>
+            <a:fillRect/>
+          </a:stretch>
+        </p:blipFill>
+        <p:spPr>
+          <a:xfrm>
+            <a:off x="4561210" y="2119762"/>
+            <a:ext cx="277612" cy="277612"/>
+          </a:xfrm>
+          <a:prstGeom prst="rect">
+            <a:avLst/>
+          </a:prstGeom>
+        </p:spPr>
+      </p:pic>
+      <p:sp>
+        <p:nvSpPr>
+          <p:cNvPr id="13" name="Text 9"/>
+          <p:cNvSpPr/>
+          <p:nvPr/>
+        </p:nvSpPr>
+        <p:spPr>
+          <a:xfrm>
+            <a:off x="3511296" y="2688336"/>
+            <a:ext cx="2377440" cy="548640"/>
+          </a:xfrm>
+          <a:prstGeom prst="rect">
+            <a:avLst/>
+          </a:prstGeom>
+          <a:noFill/>
+          <a:ln/>
+        </p:spPr>
+        <p:txBody>
+          <a:bodyPr wrap="square" lIns="0" tIns="0" rIns="0" bIns="0" rtlCol="0" anchor="ctr"/>
+          <a:lstStyle/>
+          <a:p>
+            <a:pPr algn="ctr" indent="0" marL="0">
+              <a:lnSpc>
+                <a:spcPct val="100000"/>
+              </a:lnSpc>
+              <a:buNone/>
+            </a:pPr>
+            <a:r>
+              <a:rPr lang="en-US" sz="1600" b="1" dirty="0">
+                <a:solidFill>
+                  <a:srgbClr val="1E2A36"/>
+                </a:solidFill>
+                <a:latin typeface="Calibri" pitchFamily="34" charset="0"/>
+                <a:ea typeface="Calibri" pitchFamily="34" charset="-122"/>
+                <a:cs typeface="Calibri" pitchFamily="34" charset="-120"/>
+              </a:rPr>
+              <a:t>No recording without a yes</a:t>
+            </a:r>
+            <a:endParaRPr lang="en-US" sz="1600" dirty="0"/>
+          </a:p>
+        </p:txBody>
+      </p:sp>
+      <p:sp>
+        <p:nvSpPr>
+          <p:cNvPr id="14" name="Text 10"/>
+          <p:cNvSpPr/>
+          <p:nvPr/>
+        </p:nvSpPr>
+        <p:spPr>
+          <a:xfrm>
+            <a:off x="3547872" y="3255264"/>
+            <a:ext cx="2304288" cy="548640"/>
+          </a:xfrm>
+          <a:prstGeom prst="rect">
+            <a:avLst/>
+          </a:prstGeom>
+          <a:noFill/>
+          <a:ln/>
+        </p:spPr>
+        <p:txBody>
+          <a:bodyPr wrap="square" lIns="0" tIns="0" rIns="0" bIns="0" rtlCol="0" anchor="t"/>
+          <a:lstStyle/>
+          <a:p>
+            <a:pPr algn="ctr" indent="0" marL="0">
+              <a:lnSpc>
+                <a:spcPct val="104000"/>
+              </a:lnSpc>
+              <a:buNone/>
+            </a:pPr>
+            <a:r>
+              <a:rPr lang="en-US" sz="1300" dirty="0">
+                <a:solidFill>
+                  <a:srgbClr val="5F7284"/>
+                </a:solidFill>
+                <a:latin typeface="Calibri" pitchFamily="34" charset="0"/>
+                <a:ea typeface="Calibri" pitchFamily="34" charset="-122"/>
+                <a:cs typeface="Calibri" pitchFamily="34" charset="-120"/>
+              </a:rPr>
+              <a:t>Notes are fine. Ask before you start.</a:t>
+            </a:r>
+            <a:endParaRPr lang="en-US" sz="1300" dirty="0"/>
+          </a:p>
+        </p:txBody>
+      </p:sp>
+      <p:sp>
+        <p:nvSpPr>
+          <p:cNvPr id="15" name="Shape 11"/>
+          <p:cNvSpPr/>
+          <p:nvPr/>
+        </p:nvSpPr>
+        <p:spPr>
+          <a:xfrm>
+            <a:off x="6181344" y="1737360"/>
+            <a:ext cx="2670048" cy="2148840"/>
+          </a:xfrm>
+          <a:prstGeom prst="roundRect">
+            <a:avLst>
+              <a:gd name="adj" fmla="val 3830"/>
+            </a:avLst>
+          </a:prstGeom>
+          <a:solidFill>
+            <a:srgbClr val="F2F6F8"/>
+          </a:solidFill>
+          <a:ln/>
+          <a:effectLst>
+            <a:outerShdw sx="100000" sy="100000" kx="0" ky="0" algn="bl" rotWithShape="0" blurRad="88900" dist="38100" dir="5400000">
+              <a:srgbClr val="000000">
+                <a:alpha val="13000"/>
+              </a:srgbClr>
+            </a:outerShdw>
+          </a:effectLst>
+        </p:spPr>
+      </p:sp>
+      <p:sp>
+        <p:nvSpPr>
+          <p:cNvPr id="16" name="Shape 12"/>
+          <p:cNvSpPr/>
+          <p:nvPr/>
+        </p:nvSpPr>
+        <p:spPr>
+          <a:xfrm>
+            <a:off x="7214616" y="1956816"/>
+            <a:ext cx="603504" cy="603504"/>
+          </a:xfrm>
+          <a:prstGeom prst="ellipse">
+            <a:avLst/>
+          </a:prstGeom>
+          <a:solidFill>
+            <a:srgbClr val="12908F"/>
+          </a:solidFill>
+          <a:ln/>
+        </p:spPr>
+      </p:sp>
+      <p:pic>
+        <p:nvPicPr>
+          <p:cNvPr id="17" name="Image 2" descr="preencoded.png">    </p:cNvPr>
+          <p:cNvPicPr>
+            <a:picLocks noChangeAspect="1"/>
+          </p:cNvPicPr>
+          <p:nvPr/>
+        </p:nvPicPr>
+        <p:blipFill>
+          <a:blip r:embed="rId3"/>
+          <a:stretch>
+            <a:fillRect/>
+          </a:stretch>
+        </p:blipFill>
+        <p:spPr>
+          <a:xfrm>
+            <a:off x="7377562" y="2119762"/>
+            <a:ext cx="277612" cy="277612"/>
+          </a:xfrm>
+          <a:prstGeom prst="rect">
+            <a:avLst/>
+          </a:prstGeom>
+        </p:spPr>
+      </p:pic>
+      <p:sp>
+        <p:nvSpPr>
+          <p:cNvPr id="18" name="Text 13"/>
+          <p:cNvSpPr/>
+          <p:nvPr/>
+        </p:nvSpPr>
+        <p:spPr>
+          <a:xfrm>
+            <a:off x="6327648" y="2688336"/>
+            <a:ext cx="2377440" cy="548640"/>
+          </a:xfrm>
+          <a:prstGeom prst="rect">
+            <a:avLst/>
+          </a:prstGeom>
+          <a:noFill/>
+          <a:ln/>
+        </p:spPr>
+        <p:txBody>
+          <a:bodyPr wrap="square" lIns="0" tIns="0" rIns="0" bIns="0" rtlCol="0" anchor="ctr"/>
+          <a:lstStyle/>
+          <a:p>
+            <a:pPr algn="ctr" indent="0" marL="0">
+              <a:lnSpc>
+                <a:spcPct val="100000"/>
+              </a:lnSpc>
+              <a:buNone/>
+            </a:pPr>
+            <a:r>
+              <a:rPr lang="en-US" sz="1600" b="1" dirty="0">
+                <a:solidFill>
+                  <a:srgbClr val="1E2A36"/>
+                </a:solidFill>
+                <a:latin typeface="Calibri" pitchFamily="34" charset="0"/>
+                <a:ea typeface="Calibri" pitchFamily="34" charset="-122"/>
+                <a:cs typeface="Calibri" pitchFamily="34" charset="-120"/>
+              </a:rPr>
+              <a:t>Anonymize your notes</a:t>
+            </a:r>
+            <a:endParaRPr lang="en-US" sz="1600" dirty="0"/>
+          </a:p>
+        </p:txBody>
+      </p:sp>
+      <p:sp>
+        <p:nvSpPr>
+          <p:cNvPr id="19" name="Text 14"/>
+          <p:cNvSpPr/>
+          <p:nvPr/>
+        </p:nvSpPr>
+        <p:spPr>
+          <a:xfrm>
+            <a:off x="6364224" y="3255264"/>
+            <a:ext cx="2304288" cy="548640"/>
+          </a:xfrm>
+          <a:prstGeom prst="rect">
+            <a:avLst/>
+          </a:prstGeom>
+          <a:noFill/>
+          <a:ln/>
+        </p:spPr>
+        <p:txBody>
+          <a:bodyPr wrap="square" lIns="0" tIns="0" rIns="0" bIns="0" rtlCol="0" anchor="t"/>
+          <a:lstStyle/>
+          <a:p>
+            <a:pPr algn="ctr" indent="0" marL="0">
+              <a:lnSpc>
+                <a:spcPct val="104000"/>
+              </a:lnSpc>
+              <a:buNone/>
+            </a:pPr>
+            <a:r>
+              <a:rPr lang="en-US" sz="1300" dirty="0">
+                <a:solidFill>
+                  <a:srgbClr val="5F7284"/>
+                </a:solidFill>
+                <a:latin typeface="Calibri" pitchFamily="34" charset="0"/>
+                <a:ea typeface="Calibri" pitchFamily="34" charset="-122"/>
+                <a:cs typeface="Calibri" pitchFamily="34" charset="-120"/>
+              </a:rPr>
+              <a:t>"A club officer," not a name. Collect only what you need.</a:t>
+            </a:r>
+            <a:endParaRPr lang="en-US" sz="1300" dirty="0"/>
+          </a:p>
+        </p:txBody>
+      </p:sp>
+      <p:sp>
+        <p:nvSpPr>
+          <p:cNvPr id="20" name="Shape 15"/>
+          <p:cNvSpPr/>
+          <p:nvPr/>
+        </p:nvSpPr>
+        <p:spPr>
+          <a:xfrm>
+            <a:off x="8997696" y="1737360"/>
+            <a:ext cx="2670048" cy="2148840"/>
+          </a:xfrm>
+          <a:prstGeom prst="roundRect">
+            <a:avLst>
+              <a:gd name="adj" fmla="val 3830"/>
+            </a:avLst>
+          </a:prstGeom>
+          <a:solidFill>
+            <a:srgbClr val="F2F6F8"/>
+          </a:solidFill>
+          <a:ln/>
+          <a:effectLst>
+            <a:outerShdw sx="100000" sy="100000" kx="0" ky="0" algn="bl" rotWithShape="0" blurRad="88900" dist="38100" dir="5400000">
+              <a:srgbClr val="000000">
+                <a:alpha val="13000"/>
+              </a:srgbClr>
+            </a:outerShdw>
+          </a:effectLst>
+        </p:spPr>
+      </p:sp>
+      <p:sp>
+        <p:nvSpPr>
+          <p:cNvPr id="21" name="Shape 16"/>
+          <p:cNvSpPr/>
+          <p:nvPr/>
+        </p:nvSpPr>
+        <p:spPr>
+          <a:xfrm>
+            <a:off x="10030968" y="1956816"/>
+            <a:ext cx="603504" cy="603504"/>
+          </a:xfrm>
+          <a:prstGeom prst="ellipse">
+            <a:avLst/>
+          </a:prstGeom>
+          <a:solidFill>
+            <a:srgbClr val="12908F"/>
+          </a:solidFill>
+          <a:ln/>
+        </p:spPr>
+      </p:sp>
+      <p:pic>
+        <p:nvPicPr>
+          <p:cNvPr id="22" name="Image 3" descr="preencoded.png">    </p:cNvPr>
+          <p:cNvPicPr>
+            <a:picLocks noChangeAspect="1"/>
+          </p:cNvPicPr>
+          <p:nvPr/>
+        </p:nvPicPr>
+        <p:blipFill>
+          <a:blip r:embed="rId4"/>
+          <a:stretch>
+            <a:fillRect/>
+          </a:stretch>
+        </p:blipFill>
+        <p:spPr>
+          <a:xfrm>
+            <a:off x="10193914" y="2119762"/>
+            <a:ext cx="277612" cy="277612"/>
+          </a:xfrm>
+          <a:prstGeom prst="rect">
+            <a:avLst/>
+          </a:prstGeom>
+        </p:spPr>
+      </p:pic>
+      <p:sp>
+        <p:nvSpPr>
+          <p:cNvPr id="23" name="Text 17"/>
+          <p:cNvSpPr/>
+          <p:nvPr/>
+        </p:nvSpPr>
+        <p:spPr>
+          <a:xfrm>
+            <a:off x="9144000" y="2688336"/>
+            <a:ext cx="2377440" cy="548640"/>
+          </a:xfrm>
+          <a:prstGeom prst="rect">
+            <a:avLst/>
+          </a:prstGeom>
+          <a:noFill/>
+          <a:ln/>
+        </p:spPr>
+        <p:txBody>
+          <a:bodyPr wrap="square" lIns="0" tIns="0" rIns="0" bIns="0" rtlCol="0" anchor="ctr"/>
+          <a:lstStyle/>
+          <a:p>
+            <a:pPr algn="ctr" indent="0" marL="0">
+              <a:lnSpc>
+                <a:spcPct val="100000"/>
+              </a:lnSpc>
+              <a:buNone/>
+            </a:pPr>
+            <a:r>
+              <a:rPr lang="en-US" sz="1600" b="1" dirty="0">
+                <a:solidFill>
+                  <a:srgbClr val="1E2A36"/>
+                </a:solidFill>
+                <a:latin typeface="Calibri" pitchFamily="34" charset="0"/>
+                <a:ea typeface="Calibri" pitchFamily="34" charset="-122"/>
+                <a:cs typeface="Calibri" pitchFamily="34" charset="-120"/>
+              </a:rPr>
+              <a:t>Sensitive topic? Ask me first</a:t>
+            </a:r>
+            <a:endParaRPr lang="en-US" sz="1600" dirty="0"/>
+          </a:p>
+        </p:txBody>
+      </p:sp>
+      <p:sp>
+        <p:nvSpPr>
+          <p:cNvPr id="24" name="Text 18"/>
+          <p:cNvSpPr/>
+          <p:nvPr/>
+        </p:nvSpPr>
+        <p:spPr>
+          <a:xfrm>
+            <a:off x="9180576" y="3255264"/>
+            <a:ext cx="2304288" cy="548640"/>
+          </a:xfrm>
+          <a:prstGeom prst="rect">
+            <a:avLst/>
+          </a:prstGeom>
+          <a:noFill/>
+          <a:ln/>
+        </p:spPr>
+        <p:txBody>
+          <a:bodyPr wrap="square" lIns="0" tIns="0" rIns="0" bIns="0" rtlCol="0" anchor="t"/>
+          <a:lstStyle/>
+          <a:p>
+            <a:pPr algn="ctr" indent="0" marL="0">
+              <a:lnSpc>
+                <a:spcPct val="104000"/>
+              </a:lnSpc>
+              <a:buNone/>
+            </a:pPr>
+            <a:r>
+              <a:rPr lang="en-US" sz="1300" dirty="0">
+                <a:solidFill>
+                  <a:srgbClr val="5F7284"/>
+                </a:solidFill>
+                <a:latin typeface="Calibri" pitchFamily="34" charset="0"/>
+                <a:ea typeface="Calibri" pitchFamily="34" charset="-122"/>
+                <a:cs typeface="Calibri" pitchFamily="34" charset="-120"/>
+              </a:rPr>
+              <a:t>Minors, health, legal, money trouble — before you collect.</a:t>
+            </a:r>
+            <a:endParaRPr lang="en-US" sz="1300" dirty="0"/>
+          </a:p>
+        </p:txBody>
+      </p:sp>
+      <p:sp>
+        <p:nvSpPr>
+          <p:cNvPr id="25" name="Shape 19"/>
+          <p:cNvSpPr/>
+          <p:nvPr/>
+        </p:nvSpPr>
+        <p:spPr>
+          <a:xfrm>
+            <a:off x="548640" y="4069080"/>
+            <a:ext cx="11064240" cy="1005840"/>
+          </a:xfrm>
+          <a:prstGeom prst="roundRect">
+            <a:avLst>
+              <a:gd name="adj" fmla="val 8182"/>
+            </a:avLst>
+          </a:prstGeom>
+          <a:solidFill>
+            <a:srgbClr val="14233A"/>
+          </a:solidFill>
+          <a:ln/>
+          <a:effectLst>
+            <a:outerShdw sx="100000" sy="100000" kx="0" ky="0" algn="bl" rotWithShape="0" blurRad="88900" dist="38100" dir="5400000">
+              <a:srgbClr val="000000">
+                <a:alpha val="13000"/>
+              </a:srgbClr>
+            </a:outerShdw>
+          </a:effectLst>
+        </p:spPr>
+      </p:sp>
+      <p:sp>
+        <p:nvSpPr>
+          <p:cNvPr id="26" name="Shape 20"/>
+          <p:cNvSpPr/>
+          <p:nvPr/>
+        </p:nvSpPr>
+        <p:spPr>
+          <a:xfrm>
+            <a:off x="868680" y="4306824"/>
+            <a:ext cx="530352" cy="530352"/>
+          </a:xfrm>
+          <a:prstGeom prst="ellipse">
+            <a:avLst/>
+          </a:prstGeom>
+          <a:solidFill>
+            <a:srgbClr val="E8A33D"/>
+          </a:solidFill>
+          <a:ln/>
+        </p:spPr>
+      </p:sp>
+      <p:pic>
+        <p:nvPicPr>
+          <p:cNvPr id="27" name="Image 4" descr="preencoded.png">    </p:cNvPr>
+          <p:cNvPicPr>
+            <a:picLocks noChangeAspect="1"/>
+          </p:cNvPicPr>
+          <p:nvPr/>
+        </p:nvPicPr>
+        <p:blipFill>
+          <a:blip r:embed="rId5"/>
+          <a:stretch>
+            <a:fillRect/>
+          </a:stretch>
+        </p:blipFill>
+        <p:spPr>
+          <a:xfrm>
+            <a:off x="1011875" y="4450019"/>
+            <a:ext cx="243962" cy="243962"/>
+          </a:xfrm>
+          <a:prstGeom prst="rect">
+            <a:avLst/>
+          </a:prstGeom>
+        </p:spPr>
+      </p:pic>
+      <p:sp>
+        <p:nvSpPr>
+          <p:cNvPr id="28" name="Text 21"/>
+          <p:cNvSpPr/>
+          <p:nvPr/>
+        </p:nvSpPr>
+        <p:spPr>
+          <a:xfrm>
+            <a:off x="1609344" y="4069080"/>
+            <a:ext cx="9692640" cy="1005840"/>
+          </a:xfrm>
+          <a:prstGeom prst="rect">
+            <a:avLst/>
+          </a:prstGeom>
+          <a:noFill/>
+          <a:ln/>
+        </p:spPr>
+        <p:txBody>
+          <a:bodyPr wrap="square" lIns="0" tIns="0" rIns="0" bIns="0" rtlCol="0" anchor="ctr"/>
+          <a:lstStyle/>
+          <a:p>
+            <a:pPr indent="0" marL="0">
+              <a:lnSpc>
+                <a:spcPct val="105000"/>
+              </a:lnSpc>
+              <a:buNone/>
+            </a:pPr>
+            <a:r>
+              <a:rPr lang="en-US" sz="1400" b="1" dirty="0">
+                <a:solidFill>
+                  <a:srgbClr val="E8A33D"/>
+                </a:solidFill>
+                <a:latin typeface="Calibri" pitchFamily="34" charset="0"/>
+                <a:ea typeface="Calibri" pitchFamily="34" charset="-122"/>
+                <a:cs typeface="Calibri" pitchFamily="34" charset="-120"/>
+              </a:rPr>
+              <a:t>Is this "research"? Not here.  </a:t>
+            </a:r>
+            <a:pPr indent="0" marL="0">
+              <a:lnSpc>
+                <a:spcPct val="105000"/>
+              </a:lnSpc>
+              <a:buNone/>
+            </a:pPr>
+            <a:r>
+              <a:rPr lang="en-US" sz="1400" dirty="0">
+                <a:solidFill>
+                  <a:srgbClr val="FFFFFF"/>
+                </a:solidFill>
+                <a:latin typeface="Calibri" pitchFamily="34" charset="0"/>
+                <a:ea typeface="Calibri" pitchFamily="34" charset="-122"/>
+                <a:cs typeface="Calibri" pitchFamily="34" charset="-120"/>
+              </a:rPr>
+              <a:t>A classroom project isn't research in BYU's sense, so no IRB review is needed. Ethics still apply in full — and if you ever want to publish or make generalizable claims, that DOES need IRB approval first. Ask me before you collect more data.</a:t>
+            </a:r>
+            <a:endParaRPr lang="en-US" sz="1400" dirty="0"/>
+          </a:p>
+        </p:txBody>
+      </p:sp>
+      <p:sp>
+        <p:nvSpPr>
+          <p:cNvPr id="29" name="Shape 22"/>
+          <p:cNvSpPr/>
+          <p:nvPr/>
+        </p:nvSpPr>
+        <p:spPr>
+          <a:xfrm>
+            <a:off x="548640" y="5193792"/>
+            <a:ext cx="11064240" cy="960120"/>
+          </a:xfrm>
+          <a:prstGeom prst="roundRect">
+            <a:avLst>
+              <a:gd name="adj" fmla="val 8571"/>
+            </a:avLst>
+          </a:prstGeom>
+          <a:solidFill>
+            <a:srgbClr val="FBEEDA"/>
+          </a:solidFill>
+          <a:ln/>
+          <a:effectLst>
+            <a:outerShdw sx="100000" sy="100000" kx="0" ky="0" algn="bl" rotWithShape="0" blurRad="88900" dist="38100" dir="5400000">
+              <a:srgbClr val="000000">
+                <a:alpha val="13000"/>
+              </a:srgbClr>
+            </a:outerShdw>
+          </a:effectLst>
+        </p:spPr>
+      </p:sp>
+      <p:sp>
+        <p:nvSpPr>
+          <p:cNvPr id="30" name="Text 23"/>
+          <p:cNvSpPr/>
+          <p:nvPr/>
+        </p:nvSpPr>
+        <p:spPr>
+          <a:xfrm>
+            <a:off x="868680" y="5193792"/>
+            <a:ext cx="10424160" cy="960120"/>
+          </a:xfrm>
+          <a:prstGeom prst="rect">
+            <a:avLst/>
+          </a:prstGeom>
+          <a:noFill/>
+          <a:ln/>
+        </p:spPr>
+        <p:txBody>
+          <a:bodyPr wrap="square" lIns="0" tIns="0" rIns="0" bIns="0" rtlCol="0" anchor="ctr"/>
+          <a:lstStyle/>
+          <a:p>
+            <a:pPr indent="0" marL="0">
+              <a:lnSpc>
+                <a:spcPct val="105000"/>
+              </a:lnSpc>
+              <a:buNone/>
+            </a:pPr>
+            <a:r>
+              <a:rPr lang="en-US" sz="1400" b="1" dirty="0">
+                <a:solidFill>
+                  <a:srgbClr val="0E6E6D"/>
+                </a:solidFill>
+                <a:latin typeface="Calibri" pitchFamily="34" charset="0"/>
+                <a:ea typeface="Calibri" pitchFamily="34" charset="-122"/>
+                <a:cs typeface="Calibri" pitchFamily="34" charset="-120"/>
+              </a:rPr>
+              <a:t>Watch the power imbalance.  </a:t>
+            </a:r>
+            <a:pPr indent="0" marL="0">
+              <a:lnSpc>
+                <a:spcPct val="105000"/>
+              </a:lnSpc>
+              <a:buNone/>
+            </a:pPr>
+            <a:r>
+              <a:rPr lang="en-US" sz="1400" dirty="0">
+                <a:solidFill>
+                  <a:srgbClr val="1E2A36"/>
+                </a:solidFill>
+                <a:latin typeface="Calibri" pitchFamily="34" charset="0"/>
+                <a:ea typeface="Calibri" pitchFamily="34" charset="-122"/>
+                <a:cs typeface="Calibri" pitchFamily="34" charset="-120"/>
+              </a:rPr>
+              <a:t>If someone might feel they can't say no to you — a roommate, an employee, someone you lead — a real "no" is harder to give. Pick people who can freely decline, and mean it when you offer the out.</a:t>
+            </a:r>
+            <a:endParaRPr lang="en-US" sz="1400" dirty="0"/>
+          </a:p>
+        </p:txBody>
+      </p:sp>
+      <p:sp>
+        <p:nvSpPr>
+          <p:cNvPr id="31" name="Text 24"/>
+          <p:cNvSpPr/>
+          <p:nvPr/>
+        </p:nvSpPr>
+        <p:spPr>
+          <a:xfrm>
+            <a:off x="7132320" y="6437376"/>
+            <a:ext cx="4480560" cy="274320"/>
+          </a:xfrm>
+          <a:prstGeom prst="rect">
+            <a:avLst/>
+          </a:prstGeom>
+          <a:noFill/>
+          <a:ln/>
+        </p:spPr>
+        <p:txBody>
+          <a:bodyPr wrap="square" lIns="0" tIns="0" rIns="0" bIns="0" rtlCol="0" anchor="ctr"/>
+          <a:lstStyle/>
+          <a:p>
+            <a:pPr algn="r" indent="0" marL="0">
+              <a:buNone/>
+            </a:pPr>
+            <a:r>
+              <a:rPr lang="en-US" sz="1000" dirty="0">
+                <a:solidFill>
+                  <a:srgbClr val="5F7284"/>
+                </a:solidFill>
+                <a:latin typeface="Calibri" pitchFamily="34" charset="0"/>
+                <a:ea typeface="Calibri" pitchFamily="34" charset="-122"/>
+                <a:cs typeface="Calibri" pitchFamily="34" charset="-120"/>
+              </a:rPr>
+              <a:t>CS 301R · Session 4 · Discovery Workshop</a:t>
+            </a:r>
+            <a:endParaRPr lang="en-US" sz="1000" dirty="0"/>
+          </a:p>
+        </p:txBody>
+      </p:sp>
+      <p:sp>
+        <p:nvSpPr>
+          <p:cNvPr id="32" name="Text 25"/>
+          <p:cNvSpPr/>
+          <p:nvPr/>
+        </p:nvSpPr>
+        <p:spPr>
+          <a:xfrm>
+            <a:off x="548640" y="6437376"/>
+            <a:ext cx="548640" cy="274320"/>
+          </a:xfrm>
+          <a:prstGeom prst="rect">
+            <a:avLst/>
+          </a:prstGeom>
+          <a:noFill/>
+          <a:ln/>
+        </p:spPr>
+        <p:txBody>
+          <a:bodyPr wrap="square" lIns="0" tIns="0" rIns="0" bIns="0" rtlCol="0" anchor="ctr"/>
+          <a:lstStyle/>
+          <a:p>
+            <a:pPr indent="0" marL="0">
+              <a:buNone/>
+            </a:pPr>
+            <a:r>
+              <a:rPr lang="en-US" sz="1000" dirty="0">
+                <a:solidFill>
+                  <a:srgbClr val="5F7284"/>
+                </a:solidFill>
+                <a:latin typeface="Calibri" pitchFamily="34" charset="0"/>
+                <a:ea typeface="Calibri" pitchFamily="34" charset="-122"/>
+                <a:cs typeface="Calibri" pitchFamily="34" charset="-120"/>
+              </a:rPr>
+              <a:t>8</a:t>
+            </a:r>
+            <a:endParaRPr lang="en-US" sz="1000" dirty="0"/>
+          </a:p>
+        </p:txBody>
+      </p:sp>
+    </p:spTree>
+  </p:cSld>
+  <p:clrMapOvr>
+    <a:masterClrMapping/>
+  </p:clrMapOvr>
+</p:sld>
+</file>
+
+<file path=ppt/slides/slide9.xml><?xml version="1.0" encoding="utf-8"?>
+<p:sld xmlns:a="http://schemas.openxmlformats.org/drawingml/2006/main" xmlns:r="http://schemas.openxmlformats.org/officeDocument/2006/relationships" xmlns:p="http://schemas.openxmlformats.org/presentationml/2006/main">
+  <p:cSld name="Slide 9">
+    <p:bg>
+      <p:bgPr>
+        <a:solidFill>
           <a:srgbClr val="14233A"/>
         </a:solidFill>
       </p:bgPr>
@@ -8980,450 +10569,6 @@
               <a:rPr lang="en-US" sz="1000" dirty="0">
                 <a:solidFill>
                   <a:srgbClr val="7E92A8"/>
-                </a:solidFill>
-                <a:latin typeface="Calibri" pitchFamily="34" charset="0"/>
-                <a:ea typeface="Calibri" pitchFamily="34" charset="-122"/>
-                <a:cs typeface="Calibri" pitchFamily="34" charset="-120"/>
-              </a:rPr>
-              <a:t>8</a:t>
-            </a:r>
-            <a:endParaRPr lang="en-US" sz="1000" dirty="0"/>
-          </a:p>
-        </p:txBody>
-      </p:sp>
-    </p:spTree>
-  </p:cSld>
-  <p:clrMapOvr>
-    <a:masterClrMapping/>
-  </p:clrMapOvr>
-</p:sld>
-</file>
-
-<file path=ppt/slides/slide9.xml><?xml version="1.0" encoding="utf-8"?>
-<p:sld xmlns:a="http://schemas.openxmlformats.org/drawingml/2006/main" xmlns:r="http://schemas.openxmlformats.org/officeDocument/2006/relationships" xmlns:p="http://schemas.openxmlformats.org/presentationml/2006/main">
-  <p:cSld name="Slide 9">
-    <p:bg>
-      <p:bgPr>
-        <a:solidFill>
-          <a:srgbClr val="FFFFFF"/>
-        </a:solidFill>
-      </p:bgPr>
-    </p:bg>
-    <p:spTree>
-      <p:nvGrpSpPr>
-        <p:cNvPr id="1" name=""/>
-        <p:cNvGrpSpPr/>
-        <p:nvPr/>
-      </p:nvGrpSpPr>
-      <p:grpSpPr>
-        <a:xfrm>
-          <a:off x="0" y="0"/>
-          <a:ext cx="0" cy="0"/>
-          <a:chOff x="0" y="0"/>
-          <a:chExt cx="0" cy="0"/>
-        </a:xfrm>
-      </p:grpSpPr>
-      <p:sp>
-        <p:nvSpPr>
-          <p:cNvPr id="2" name="Shape 0"/>
-          <p:cNvSpPr/>
-          <p:nvPr/>
-        </p:nvSpPr>
-        <p:spPr>
-          <a:xfrm>
-            <a:off x="566928" y="502920"/>
-            <a:ext cx="137160" cy="137160"/>
-          </a:xfrm>
-          <a:prstGeom prst="ellipse">
-            <a:avLst/>
-          </a:prstGeom>
-          <a:solidFill>
-            <a:srgbClr val="E8A33D"/>
-          </a:solidFill>
-          <a:ln/>
-        </p:spPr>
-      </p:sp>
-      <p:sp>
-        <p:nvSpPr>
-          <p:cNvPr id="3" name="Text 1"/>
-          <p:cNvSpPr/>
-          <p:nvPr/>
-        </p:nvSpPr>
-        <p:spPr>
-          <a:xfrm>
-            <a:off x="795528" y="402336"/>
-            <a:ext cx="10515600" cy="310896"/>
-          </a:xfrm>
-          <a:prstGeom prst="rect">
-            <a:avLst/>
-          </a:prstGeom>
-          <a:noFill/>
-          <a:ln/>
-        </p:spPr>
-        <p:txBody>
-          <a:bodyPr wrap="square" lIns="0" tIns="0" rIns="0" bIns="0" rtlCol="0" anchor="ctr"/>
-          <a:lstStyle/>
-          <a:p>
-            <a:pPr indent="0" marL="0">
-              <a:buNone/>
-            </a:pPr>
-            <a:r>
-              <a:rPr lang="en-US" sz="1400" b="1" spc="200" kern="0" dirty="0">
-                <a:solidFill>
-                  <a:srgbClr val="12908F"/>
-                </a:solidFill>
-                <a:latin typeface="Calibri" pitchFamily="34" charset="0"/>
-                <a:ea typeface="Calibri" pitchFamily="34" charset="-122"/>
-                <a:cs typeface="Calibri" pitchFamily="34" charset="-120"/>
-              </a:rPr>
-              <a:t>WHEN YOU CAN'T REACH A REAL USER</a:t>
-            </a:r>
-            <a:endParaRPr lang="en-US" sz="1400" dirty="0"/>
-          </a:p>
-        </p:txBody>
-      </p:sp>
-      <p:sp>
-        <p:nvSpPr>
-          <p:cNvPr id="4" name="Text 2"/>
-          <p:cNvSpPr/>
-          <p:nvPr/>
-        </p:nvSpPr>
-        <p:spPr>
-          <a:xfrm>
-            <a:off x="548640" y="749808"/>
-            <a:ext cx="11064240" cy="914400"/>
-          </a:xfrm>
-          <a:prstGeom prst="rect">
-            <a:avLst/>
-          </a:prstGeom>
-          <a:noFill/>
-          <a:ln/>
-        </p:spPr>
-        <p:txBody>
-          <a:bodyPr wrap="square" lIns="0" tIns="0" rIns="0" bIns="0" rtlCol="0" anchor="t"/>
-          <a:lstStyle/>
-          <a:p>
-            <a:pPr indent="0" marL="0">
-              <a:buNone/>
-            </a:pPr>
-            <a:r>
-              <a:rPr lang="en-US" sz="3100" b="1" dirty="0">
-                <a:solidFill>
-                  <a:srgbClr val="1E2A36"/>
-                </a:solidFill>
-                <a:latin typeface="Cambria" pitchFamily="34" charset="0"/>
-                <a:ea typeface="Cambria" pitchFamily="34" charset="-122"/>
-                <a:cs typeface="Cambria" pitchFamily="34" charset="-120"/>
-              </a:rPr>
-              <a:t>Build an honest persona</a:t>
-            </a:r>
-            <a:endParaRPr lang="en-US" sz="3100" dirty="0"/>
-          </a:p>
-        </p:txBody>
-      </p:sp>
-      <p:sp>
-        <p:nvSpPr>
-          <p:cNvPr id="5" name="Shape 3"/>
-          <p:cNvSpPr/>
-          <p:nvPr/>
-        </p:nvSpPr>
-        <p:spPr>
-          <a:xfrm>
-            <a:off x="548640" y="1920240"/>
-            <a:ext cx="11064240" cy="1371600"/>
-          </a:xfrm>
-          <a:prstGeom prst="roundRect">
-            <a:avLst>
-              <a:gd name="adj" fmla="val 6000"/>
-            </a:avLst>
-          </a:prstGeom>
-          <a:solidFill>
-            <a:srgbClr val="F2F6F8"/>
-          </a:solidFill>
-          <a:ln/>
-          <a:effectLst>
-            <a:outerShdw sx="100000" sy="100000" kx="0" ky="0" algn="bl" rotWithShape="0" blurRad="88900" dist="38100" dir="5400000">
-              <a:srgbClr val="000000">
-                <a:alpha val="13000"/>
-              </a:srgbClr>
-            </a:outerShdw>
-          </a:effectLst>
-        </p:spPr>
-      </p:sp>
-      <p:sp>
-        <p:nvSpPr>
-          <p:cNvPr id="6" name="Shape 4"/>
-          <p:cNvSpPr/>
-          <p:nvPr/>
-        </p:nvSpPr>
-        <p:spPr>
-          <a:xfrm>
-            <a:off x="914400" y="2331720"/>
-            <a:ext cx="640080" cy="640080"/>
-          </a:xfrm>
-          <a:prstGeom prst="ellipse">
-            <a:avLst/>
-          </a:prstGeom>
-          <a:solidFill>
-            <a:srgbClr val="12908F"/>
-          </a:solidFill>
-          <a:ln/>
-        </p:spPr>
-      </p:sp>
-      <p:pic>
-        <p:nvPicPr>
-          <p:cNvPr id="7" name="Image 0" descr="preencoded.png">    </p:cNvPr>
-          <p:cNvPicPr>
-            <a:picLocks noChangeAspect="1"/>
-          </p:cNvPicPr>
-          <p:nvPr/>
-        </p:nvPicPr>
-        <p:blipFill>
-          <a:blip r:embed="rId1"/>
-          <a:stretch>
-            <a:fillRect/>
-          </a:stretch>
-        </p:blipFill>
-        <p:spPr>
-          <a:xfrm>
-            <a:off x="1087222" y="2504542"/>
-            <a:ext cx="294437" cy="294437"/>
-          </a:xfrm>
-          <a:prstGeom prst="rect">
-            <a:avLst/>
-          </a:prstGeom>
-        </p:spPr>
-      </p:pic>
-      <p:sp>
-        <p:nvSpPr>
-          <p:cNvPr id="8" name="Text 5"/>
-          <p:cNvSpPr/>
-          <p:nvPr/>
-        </p:nvSpPr>
-        <p:spPr>
-          <a:xfrm>
-            <a:off x="1828800" y="1920240"/>
-            <a:ext cx="9509760" cy="1371600"/>
-          </a:xfrm>
-          <a:prstGeom prst="rect">
-            <a:avLst/>
-          </a:prstGeom>
-          <a:noFill/>
-          <a:ln/>
-        </p:spPr>
-        <p:txBody>
-          <a:bodyPr wrap="square" lIns="0" tIns="0" rIns="0" bIns="0" rtlCol="0" anchor="ctr"/>
-          <a:lstStyle/>
-          <a:p>
-            <a:pPr indent="0" marL="0">
-              <a:lnSpc>
-                <a:spcPct val="105000"/>
-              </a:lnSpc>
-              <a:buNone/>
-            </a:pPr>
-            <a:r>
-              <a:rPr lang="en-US" sz="1700" dirty="0">
-                <a:solidFill>
-                  <a:srgbClr val="1E2A36"/>
-                </a:solidFill>
-                <a:latin typeface="Calibri" pitchFamily="34" charset="0"/>
-                <a:ea typeface="Calibri" pitchFamily="34" charset="-122"/>
-                <a:cs typeface="Calibri" pitchFamily="34" charset="-120"/>
-              </a:rPr>
-              <a:t>A persona here is NOT an invented character — it's a summary of what you actually found, with every claim labeled.</a:t>
-            </a:r>
-            <a:endParaRPr lang="en-US" sz="1700" dirty="0"/>
-          </a:p>
-        </p:txBody>
-      </p:sp>
-      <p:sp>
-        <p:nvSpPr>
-          <p:cNvPr id="9" name="Text 6"/>
-          <p:cNvSpPr/>
-          <p:nvPr/>
-        </p:nvSpPr>
-        <p:spPr>
-          <a:xfrm>
-            <a:off x="548640" y="3520440"/>
-            <a:ext cx="10972800" cy="365760"/>
-          </a:xfrm>
-          <a:prstGeom prst="rect">
-            <a:avLst/>
-          </a:prstGeom>
-          <a:noFill/>
-          <a:ln/>
-        </p:spPr>
-        <p:txBody>
-          <a:bodyPr wrap="square" lIns="0" tIns="0" rIns="0" bIns="0" rtlCol="0" anchor="ctr"/>
-          <a:lstStyle/>
-          <a:p>
-            <a:pPr indent="0" marL="0">
-              <a:buNone/>
-            </a:pPr>
-            <a:r>
-              <a:rPr lang="en-US" sz="1600" b="1" dirty="0">
-                <a:solidFill>
-                  <a:srgbClr val="0E6E6D"/>
-                </a:solidFill>
-                <a:latin typeface="Calibri" pitchFamily="34" charset="0"/>
-                <a:ea typeface="Calibri" pitchFamily="34" charset="-122"/>
-                <a:cs typeface="Calibri" pitchFamily="34" charset="-120"/>
-              </a:rPr>
-              <a:t>"Documented honestly" means:</a:t>
-            </a:r>
-            <a:endParaRPr lang="en-US" sz="1600" dirty="0"/>
-          </a:p>
-        </p:txBody>
-      </p:sp>
-      <p:sp>
-        <p:nvSpPr>
-          <p:cNvPr id="10" name="Text 7"/>
-          <p:cNvSpPr/>
-          <p:nvPr/>
-        </p:nvSpPr>
-        <p:spPr>
-          <a:xfrm>
-            <a:off x="914400" y="3931920"/>
-            <a:ext cx="10515600" cy="1828800"/>
-          </a:xfrm>
-          <a:prstGeom prst="rect">
-            <a:avLst/>
-          </a:prstGeom>
-          <a:noFill/>
-          <a:ln/>
-        </p:spPr>
-        <p:txBody>
-          <a:bodyPr wrap="square" lIns="0" tIns="0" rIns="0" bIns="0" rtlCol="0" anchor="t"/>
-          <a:lstStyle/>
-          <a:p>
-            <a:pPr marL="203200" indent="-203200">
-              <a:spcAft>
-                <a:spcPts val="1100"/>
-              </a:spcAft>
-              <a:buSzPct val="100000"/>
-              <a:buChar char="•"/>
-            </a:pPr>
-            <a:r>
-              <a:rPr lang="en-US" sz="1600" dirty="0">
-                <a:solidFill>
-                  <a:srgbClr val="1E2A36"/>
-                </a:solidFill>
-                <a:latin typeface="Calibri" pitchFamily="34" charset="0"/>
-                <a:ea typeface="Calibri" pitchFamily="34" charset="-122"/>
-                <a:cs typeface="Calibri" pitchFamily="34" charset="-120"/>
-              </a:rPr>
-              <a:t>Tag every claim: [E] evidence (with a source) or [A] assumption (a labeled guess)</a:t>
-            </a:r>
-            <a:endParaRPr lang="en-US" sz="1600" dirty="0"/>
-          </a:p>
-          <a:p>
-            <a:pPr marL="203200" indent="-203200">
-              <a:spcAft>
-                <a:spcPts val="1100"/>
-              </a:spcAft>
-              <a:buSzPct val="100000"/>
-              <a:buChar char="•"/>
-            </a:pPr>
-            <a:r>
-              <a:rPr lang="en-US" sz="1600" dirty="0">
-                <a:solidFill>
-                  <a:srgbClr val="1E2A36"/>
-                </a:solidFill>
-                <a:latin typeface="Calibri" pitchFamily="34" charset="0"/>
-                <a:ea typeface="Calibri" pitchFamily="34" charset="-122"/>
-                <a:cs typeface="Calibri" pitchFamily="34" charset="-120"/>
-              </a:rPr>
-              <a:t>No invented facts — a guess is marked [A], never dressed up as fact</a:t>
-            </a:r>
-            <a:endParaRPr lang="en-US" sz="1600" dirty="0"/>
-          </a:p>
-          <a:p>
-            <a:pPr marL="203200" indent="-203200">
-              <a:buSzPct val="100000"/>
-              <a:buChar char="•"/>
-            </a:pPr>
-            <a:r>
-              <a:rPr lang="en-US" sz="1600" dirty="0">
-                <a:solidFill>
-                  <a:srgbClr val="1E2A36"/>
-                </a:solidFill>
-                <a:latin typeface="Calibri" pitchFamily="34" charset="0"/>
-                <a:ea typeface="Calibri" pitchFamily="34" charset="-122"/>
-                <a:cs typeface="Calibri" pitchFamily="34" charset="-120"/>
-              </a:rPr>
-              <a:t>List your sources, and the top assumptions you'd verify in a real conversation</a:t>
-            </a:r>
-            <a:endParaRPr lang="en-US" sz="1600" dirty="0"/>
-          </a:p>
-        </p:txBody>
-      </p:sp>
-      <p:sp>
-        <p:nvSpPr>
-          <p:cNvPr id="11" name="Text 8"/>
-          <p:cNvSpPr/>
-          <p:nvPr/>
-        </p:nvSpPr>
-        <p:spPr>
-          <a:xfrm>
-            <a:off x="7132320" y="6437376"/>
-            <a:ext cx="4480560" cy="274320"/>
-          </a:xfrm>
-          <a:prstGeom prst="rect">
-            <a:avLst/>
-          </a:prstGeom>
-          <a:noFill/>
-          <a:ln/>
-        </p:spPr>
-        <p:txBody>
-          <a:bodyPr wrap="square" lIns="0" tIns="0" rIns="0" bIns="0" rtlCol="0" anchor="ctr"/>
-          <a:lstStyle/>
-          <a:p>
-            <a:pPr algn="r" indent="0" marL="0">
-              <a:buNone/>
-            </a:pPr>
-            <a:r>
-              <a:rPr lang="en-US" sz="1000" dirty="0">
-                <a:solidFill>
-                  <a:srgbClr val="5F7284"/>
-                </a:solidFill>
-                <a:latin typeface="Calibri" pitchFamily="34" charset="0"/>
-                <a:ea typeface="Calibri" pitchFamily="34" charset="-122"/>
-                <a:cs typeface="Calibri" pitchFamily="34" charset="-120"/>
-              </a:rPr>
-              <a:t>CS 301R · Session 4 · Discovery Workshop</a:t>
-            </a:r>
-            <a:endParaRPr lang="en-US" sz="1000" dirty="0"/>
-          </a:p>
-        </p:txBody>
-      </p:sp>
-      <p:sp>
-        <p:nvSpPr>
-          <p:cNvPr id="12" name="Text 9"/>
-          <p:cNvSpPr/>
-          <p:nvPr/>
-        </p:nvSpPr>
-        <p:spPr>
-          <a:xfrm>
-            <a:off x="548640" y="6437376"/>
-            <a:ext cx="548640" cy="274320"/>
-          </a:xfrm>
-          <a:prstGeom prst="rect">
-            <a:avLst/>
-          </a:prstGeom>
-          <a:noFill/>
-          <a:ln/>
-        </p:spPr>
-        <p:txBody>
-          <a:bodyPr wrap="square" lIns="0" tIns="0" rIns="0" bIns="0" rtlCol="0" anchor="ctr"/>
-          <a:lstStyle/>
-          <a:p>
-            <a:pPr indent="0" marL="0">
-              <a:buNone/>
-            </a:pPr>
-            <a:r>
-              <a:rPr lang="en-US" sz="1000" dirty="0">
-                <a:solidFill>
-                  <a:srgbClr val="5F7284"/>
                 </a:solidFill>
                 <a:latin typeface="Calibri" pitchFamily="34" charset="0"/>
                 <a:ea typeface="Calibri" pitchFamily="34" charset="-122"/>

</xml_diff>